<commit_message>
Remove non-existing OSH stability rating
</commit_message>
<xml_diff>
--- a/src/report_generator/presets/templates/portfolio-metrics.pptx
+++ b/src/report_generator/presets/templates/portfolio-metrics.pptx
@@ -6,10 +6,10 @@
     <p:sldMasterId id="2147483794" r:id="rId5"/>
   </p:sldMasterIdLst>
   <p:notesMasterIdLst>
-    <p:notesMasterId r:id="rId50"/>
+    <p:notesMasterId r:id="rId49"/>
   </p:notesMasterIdLst>
   <p:handoutMasterIdLst>
-    <p:handoutMasterId r:id="rId51"/>
+    <p:handoutMasterId r:id="rId50"/>
   </p:handoutMasterIdLst>
   <p:sldIdLst>
     <p:sldId id="1973" r:id="rId6"/>
@@ -55,7 +55,6 @@
     <p:sldId id="11637" r:id="rId46"/>
     <p:sldId id="11638" r:id="rId47"/>
     <p:sldId id="11639" r:id="rId48"/>
-    <p:sldId id="11640" r:id="rId49"/>
   </p:sldIdLst>
   <p:sldSz cx="12192000" cy="6858000"/>
   <p:notesSz cx="6858000" cy="9144000"/>
@@ -206,7 +205,6 @@
             <p14:sldId id="11637"/>
             <p14:sldId id="11638"/>
             <p14:sldId id="11639"/>
-            <p14:sldId id="11640"/>
           </p14:sldIdLst>
         </p14:section>
       </p14:sectionLst>
@@ -46936,1058 +46934,6 @@
 </p:sld>
 </file>
 
-<file path=ppt/slides/slide44.xml><?xml version="1.0" encoding="utf-8"?>
-<p:sld xmlns:a="http://schemas.openxmlformats.org/drawingml/2006/main" xmlns:r="http://schemas.openxmlformats.org/officeDocument/2006/relationships" xmlns:p="http://schemas.openxmlformats.org/presentationml/2006/main">
-  <p:cSld>
-    <p:spTree>
-      <p:nvGrpSpPr>
-        <p:cNvPr id="1" name=""/>
-        <p:cNvGrpSpPr/>
-        <p:nvPr/>
-      </p:nvGrpSpPr>
-      <p:grpSpPr>
-        <a:xfrm>
-          <a:off x="0" y="0"/>
-          <a:ext cx="0" cy="0"/>
-          <a:chOff x="0" y="0"/>
-          <a:chExt cx="0" cy="0"/>
-        </a:xfrm>
-      </p:grpSpPr>
-      <p:sp>
-        <p:nvSpPr>
-          <p:cNvPr id="2" name="Text Placeholder 1"/>
-          <p:cNvSpPr>
-            <a:spLocks noGrp="1"/>
-          </p:cNvSpPr>
-          <p:nvPr>
-            <p:ph type="body" sz="quarter" idx="12"/>
-          </p:nvPr>
-        </p:nvSpPr>
-        <p:spPr>
-          <a:xfrm>
-            <a:off x="381600" y="129568"/>
-            <a:ext cx="1663129" cy="228209"/>
-          </a:xfrm>
-        </p:spPr>
-        <p:txBody>
-          <a:bodyPr>
-            <a:spAutoFit/>
-          </a:bodyPr>
-          <a:lstStyle/>
-          <a:p>
-            <a:r>
-              <a:rPr lang="en-US" dirty="0"/>
-              <a:t>Open Source Health</a:t>
-            </a:r>
-          </a:p>
-        </p:txBody>
-      </p:sp>
-      <p:sp>
-        <p:nvSpPr>
-          <p:cNvPr id="3" name="Content Placeholder 2"/>
-          <p:cNvSpPr>
-            <a:spLocks noGrp="1"/>
-          </p:cNvSpPr>
-          <p:nvPr>
-            <p:ph sz="quarter" idx="13"/>
-          </p:nvPr>
-        </p:nvSpPr>
-        <p:spPr/>
-        <p:txBody>
-          <a:bodyPr/>
-          <a:lstStyle/>
-          <a:p>
-            <a:endParaRPr/>
-          </a:p>
-        </p:txBody>
-      </p:sp>
-      <p:sp>
-        <p:nvSpPr>
-          <p:cNvPr id="4" name="Title 3"/>
-          <p:cNvSpPr>
-            <a:spLocks noGrp="1"/>
-          </p:cNvSpPr>
-          <p:nvPr>
-            <p:ph type="title"/>
-          </p:nvPr>
-        </p:nvSpPr>
-        <p:spPr/>
-        <p:txBody>
-          <a:bodyPr>
-            <a:spAutoFit/>
-          </a:bodyPr>
-          <a:lstStyle/>
-          <a:p>
-            <a:r>
-              <a:rPr lang="en-US" dirty="0"/>
-              <a:t>Overview of Stability metric for portfolio CUSTOMER_NAME</a:t>
-            </a:r>
-          </a:p>
-        </p:txBody>
-      </p:sp>
-      <p:sp>
-        <p:nvSpPr>
-          <p:cNvPr id="7" name="Rectangle 6">
-            <a:extLst>
-              <a:ext uri="{FF2B5EF4-FFF2-40B4-BE49-F238E27FC236}">
-                <a16:creationId xmlns:a16="http://schemas.microsoft.com/office/drawing/2014/main" id="{4D956AE0-666A-B966-0B15-61A5E6C88F75}"/>
-              </a:ext>
-            </a:extLst>
-          </p:cNvPr>
-          <p:cNvSpPr/>
-          <p:nvPr/>
-        </p:nvSpPr>
-        <p:spPr>
-          <a:xfrm>
-            <a:off x="0" y="1390132"/>
-            <a:ext cx="12192000" cy="4927867"/>
-          </a:xfrm>
-          <a:prstGeom prst="rect">
-            <a:avLst/>
-          </a:prstGeom>
-          <a:solidFill>
-            <a:schemeClr val="bg1"/>
-          </a:solidFill>
-          <a:ln>
-            <a:noFill/>
-          </a:ln>
-          <a:effectLst>
-            <a:outerShdw blurRad="190500" dist="38100" dir="2700000" algn="tl" rotWithShape="0">
-              <a:prstClr val="black">
-                <a:alpha val="15000"/>
-              </a:prstClr>
-            </a:outerShdw>
-          </a:effectLst>
-        </p:spPr>
-        <p:style>
-          <a:lnRef idx="2">
-            <a:schemeClr val="accent1">
-              <a:shade val="50000"/>
-            </a:schemeClr>
-          </a:lnRef>
-          <a:fillRef idx="1">
-            <a:schemeClr val="accent1"/>
-          </a:fillRef>
-          <a:effectRef idx="0">
-            <a:schemeClr val="accent1"/>
-          </a:effectRef>
-          <a:fontRef idx="minor">
-            <a:schemeClr val="lt1"/>
-          </a:fontRef>
-        </p:style>
-        <p:txBody>
-          <a:bodyPr lIns="731520" tIns="72000" rIns="108000" bIns="72000" rtlCol="0" anchor="ctr"/>
-          <a:lstStyle/>
-          <a:p>
-            <a:endParaRPr lang="nl-NL" sz="1200" b="1" noProof="0" dirty="0">
-              <a:solidFill>
-                <a:schemeClr val="accent1"/>
-              </a:solidFill>
-            </a:endParaRPr>
-          </a:p>
-        </p:txBody>
-      </p:sp>
-      <p:sp>
-        <p:nvSpPr>
-          <p:cNvPr id="5" name="Rectangle 1">
-            <a:extLst>
-              <a:ext uri="{FF2B5EF4-FFF2-40B4-BE49-F238E27FC236}">
-                <a16:creationId xmlns:a16="http://schemas.microsoft.com/office/drawing/2014/main" id="{5865897F-56E3-D0DA-D709-1ABB8A25DE16}"/>
-              </a:ext>
-            </a:extLst>
-          </p:cNvPr>
-          <p:cNvSpPr/>
-          <p:nvPr/>
-        </p:nvSpPr>
-        <p:spPr>
-          <a:xfrm>
-            <a:off x="661616" y="2961823"/>
-            <a:ext cx="10867079" cy="2905513"/>
-          </a:xfrm>
-          <a:prstGeom prst="rect">
-            <a:avLst/>
-          </a:prstGeom>
-          <a:solidFill>
-            <a:srgbClr val="F0089F"/>
-          </a:solidFill>
-          <a:ln>
-            <a:noFill/>
-          </a:ln>
-        </p:spPr>
-        <p:style>
-          <a:lnRef idx="2">
-            <a:schemeClr val="accent1">
-              <a:shade val="50000"/>
-            </a:schemeClr>
-          </a:lnRef>
-          <a:fillRef idx="1">
-            <a:schemeClr val="accent1"/>
-          </a:fillRef>
-          <a:effectRef idx="0">
-            <a:schemeClr val="accent1"/>
-          </a:effectRef>
-          <a:fontRef idx="minor">
-            <a:schemeClr val="lt1"/>
-          </a:fontRef>
-        </p:style>
-        <p:txBody>
-          <a:bodyPr lIns="108000" tIns="72000" rIns="108000" bIns="72000" rtlCol="0" anchor="ctr"/>
-          <a:lstStyle/>
-          <a:p>
-            <a:pPr algn="ctr"/>
-            <a:r>
-              <a:rPr lang="en-US" sz="1600" dirty="0">
-                <a:solidFill>
-                  <a:schemeClr val="bg1"/>
-                </a:solidFill>
-              </a:rPr>
-              <a:t>PORTFOLIO_PERIOD_OSH_STABILITY_GROUPED_BY_TEAM</a:t>
-            </a:r>
-          </a:p>
-        </p:txBody>
-      </p:sp>
-      <p:sp>
-        <p:nvSpPr>
-          <p:cNvPr id="1071" name="TextBox 1071"/>
-          <p:cNvSpPr txBox="1"/>
-          <p:nvPr/>
-        </p:nvSpPr>
-        <p:spPr>
-          <a:xfrm>
-            <a:off x="2817202" y="5844428"/>
-            <a:ext cx="1276460" cy="223844"/>
-          </a:xfrm>
-          <a:prstGeom prst="rect">
-            <a:avLst/>
-          </a:prstGeom>
-          <a:noFill/>
-        </p:spPr>
-        <p:txBody>
-          <a:bodyPr wrap="none" lIns="90000" rtlCol="0" anchor="t">
-            <a:spAutoFit/>
-          </a:bodyPr>
-          <a:lstStyle/>
-          <a:p>
-            <a:pPr algn="l">
-              <a:lnSpc>
-                <a:spcPct val="113000"/>
-              </a:lnSpc>
-            </a:pPr>
-            <a:r>
-              <a:rPr lang="en-GB" sz="800" dirty="0">
-                <a:solidFill>
-                  <a:schemeClr val="tx2"/>
-                </a:solidFill>
-              </a:rPr>
-              <a:t>Systems grouped by </a:t>
-            </a:r>
-            <a:r>
-              <a:rPr lang="en-GB" sz="800" b="1" dirty="0">
-                <a:solidFill>
-                  <a:schemeClr val="tx2"/>
-                </a:solidFill>
-              </a:rPr>
-              <a:t>Team</a:t>
-            </a:r>
-          </a:p>
-        </p:txBody>
-      </p:sp>
-      <p:sp>
-        <p:nvSpPr>
-          <p:cNvPr id="1060" name="TextBox 1060"/>
-          <p:cNvSpPr txBox="1"/>
-          <p:nvPr/>
-        </p:nvSpPr>
-        <p:spPr>
-          <a:xfrm>
-            <a:off x="223094" y="1411288"/>
-            <a:ext cx="11515250" cy="1560512"/>
-          </a:xfrm>
-          <a:prstGeom prst="rect">
-            <a:avLst/>
-          </a:prstGeom>
-        </p:spPr>
-        <p:txBody>
-          <a:bodyPr lIns="91440" tIns="45720" rIns="91440" bIns="45720" anchor="t"/>
-          <a:lstStyle>
-            <a:lvl1pPr marL="0" indent="-284400" algn="l" defTabSz="914400" rtl="0" eaLnBrk="1" latinLnBrk="0" hangingPunct="1">
-              <a:lnSpc>
-                <a:spcPct val="114000"/>
-              </a:lnSpc>
-              <a:spcBef>
-                <a:spcPts val="0"/>
-              </a:spcBef>
-              <a:spcAft>
-                <a:spcPts val="600"/>
-              </a:spcAft>
-              <a:buClr>
-                <a:srgbClr val="1864FF"/>
-              </a:buClr>
-              <a:buFont typeface="Arial" panose="020B0604020202020204" pitchFamily="34" charset="0"/>
-              <a:buChar char="•"/>
-              <a:defRPr lang="en-US" sz="1600" kern="1200" smtClean="0">
-                <a:solidFill>
-                  <a:schemeClr val="tx1"/>
-                </a:solidFill>
-                <a:latin typeface="+mn-lt"/>
-                <a:ea typeface="+mn-ea"/>
-                <a:cs typeface="+mn-cs"/>
-              </a:defRPr>
-            </a:lvl1pPr>
-          </a:lstStyle>
-          <a:p>
-            <a:pPr indent="-283845"/>
-            <a:r>
-              <a:rPr lang="en-US" dirty="0"/>
-              <a:t>The average Stability rating for the portfolio is PORTFOLIO_OSH_AVG_RATING_STABILITY</a:t>
-            </a:r>
-            <a:r>
-              <a:rPr lang="en-US" sz="100" dirty="0"/>
-              <a:t> </a:t>
-            </a:r>
-            <a:r>
-              <a:rPr lang="en-US" dirty="0"/>
-              <a:t>★.</a:t>
-            </a:r>
-          </a:p>
-          <a:p>
-            <a:pPr indent="-283845"/>
-            <a:r>
-              <a:rPr lang="en-US" dirty="0"/>
-              <a:t>PORTFOLIO_OSH_ABOVE_MARKET_STABILITY</a:t>
-            </a:r>
-            <a:r>
-              <a:rPr lang="en-GB" sz="1550" noProof="0" dirty="0"/>
-              <a:t>% of systems score above market average (≥3.5</a:t>
-            </a:r>
-            <a:r>
-              <a:rPr lang="en-US" sz="1400" dirty="0"/>
-              <a:t>★</a:t>
-            </a:r>
-            <a:r>
-              <a:rPr lang="en-GB" sz="1550" noProof="0" dirty="0"/>
-              <a:t>).</a:t>
-            </a:r>
-          </a:p>
-          <a:p>
-            <a:pPr indent="-283845"/>
-            <a:r>
-              <a:rPr lang="en-US" dirty="0"/>
-              <a:t>PORTFOLIO_OSH_MARKET_AVERAGE_STABILITY</a:t>
-            </a:r>
-            <a:r>
-              <a:rPr lang="en-GB" sz="1550" dirty="0">
-                <a:ea typeface="Calibri"/>
-                <a:cs typeface="Calibri"/>
-              </a:rPr>
-              <a:t>% of systems score market average (3</a:t>
-            </a:r>
-            <a:r>
-              <a:rPr lang="en-US" sz="1400" dirty="0"/>
-              <a:t>★</a:t>
-            </a:r>
-            <a:r>
-              <a:rPr lang="en-GB" sz="1550" dirty="0">
-                <a:ea typeface="Calibri"/>
-                <a:cs typeface="Calibri"/>
-              </a:rPr>
-              <a:t>).</a:t>
-            </a:r>
-          </a:p>
-          <a:p>
-            <a:pPr indent="-283845"/>
-            <a:r>
-              <a:rPr lang="en-US" dirty="0"/>
-              <a:t>PORTFOLIO_OSH_BELOW_MARKET_STABILITY</a:t>
-            </a:r>
-            <a:r>
-              <a:rPr lang="en-GB" sz="1550" dirty="0">
-                <a:ea typeface="Calibri"/>
-                <a:cs typeface="Calibri"/>
-              </a:rPr>
-              <a:t>% of systems score below market average (≤2.5</a:t>
-            </a:r>
-            <a:r>
-              <a:rPr lang="en-US" sz="1400" dirty="0"/>
-              <a:t>★</a:t>
-            </a:r>
-            <a:r>
-              <a:rPr lang="en-GB" sz="1550" dirty="0">
-                <a:ea typeface="Calibri"/>
-                <a:cs typeface="Calibri"/>
-              </a:rPr>
-              <a:t>).</a:t>
-            </a:r>
-          </a:p>
-        </p:txBody>
-      </p:sp>
-      <p:grpSp>
-        <p:nvGrpSpPr>
-          <p:cNvPr id="6" name="Group 1030">
-            <a:extLst>
-              <a:ext uri="{FF2B5EF4-FFF2-40B4-BE49-F238E27FC236}">
-                <a16:creationId xmlns:a16="http://schemas.microsoft.com/office/drawing/2014/main" id="{513B02F0-2AA1-5FFD-D5C4-7347F2421D8B}"/>
-              </a:ext>
-            </a:extLst>
-          </p:cNvPr>
-          <p:cNvGrpSpPr/>
-          <p:nvPr/>
-        </p:nvGrpSpPr>
-        <p:grpSpPr>
-          <a:xfrm>
-            <a:off x="690538" y="5907042"/>
-            <a:ext cx="300732" cy="98617"/>
-            <a:chOff x="586253" y="6116391"/>
-            <a:chExt cx="300732" cy="98617"/>
-          </a:xfrm>
-        </p:grpSpPr>
-        <p:sp>
-          <p:nvSpPr>
-            <p:cNvPr id="8" name="TextBox 1031">
-              <a:extLst>
-                <a:ext uri="{FF2B5EF4-FFF2-40B4-BE49-F238E27FC236}">
-                  <a16:creationId xmlns:a16="http://schemas.microsoft.com/office/drawing/2014/main" id="{0F18060E-AAC3-E654-127C-6597327BF936}"/>
-                </a:ext>
-              </a:extLst>
-            </p:cNvPr>
-            <p:cNvSpPr txBox="1"/>
-            <p:nvPr/>
-          </p:nvSpPr>
-          <p:spPr>
-            <a:xfrm>
-              <a:off x="710655" y="6116391"/>
-              <a:ext cx="176330" cy="98617"/>
-            </a:xfrm>
-            <a:prstGeom prst="rect">
-              <a:avLst/>
-            </a:prstGeom>
-            <a:noFill/>
-          </p:spPr>
-          <p:txBody>
-            <a:bodyPr wrap="none" lIns="0" tIns="0" rIns="0" bIns="0" rtlCol="0" anchor="t">
-              <a:spAutoFit/>
-            </a:bodyPr>
-            <a:lstStyle/>
-            <a:p>
-              <a:pPr algn="l">
-                <a:lnSpc>
-                  <a:spcPct val="113000"/>
-                </a:lnSpc>
-              </a:pPr>
-              <a:r>
-                <a:rPr lang="en-GB" sz="800" dirty="0">
-                  <a:solidFill>
-                    <a:schemeClr val="tx2"/>
-                  </a:solidFill>
-                </a:rPr>
-                <a:t>1 star</a:t>
-              </a:r>
-            </a:p>
-          </p:txBody>
-        </p:sp>
-        <p:sp>
-          <p:nvSpPr>
-            <p:cNvPr id="9" name="Rounded Rectangle 1032">
-              <a:extLst>
-                <a:ext uri="{FF2B5EF4-FFF2-40B4-BE49-F238E27FC236}">
-                  <a16:creationId xmlns:a16="http://schemas.microsoft.com/office/drawing/2014/main" id="{D2A7757E-779F-2810-5E4E-E62E1A0BAF2F}"/>
-                </a:ext>
-              </a:extLst>
-            </p:cNvPr>
-            <p:cNvSpPr>
-              <a:spLocks noChangeAspect="1"/>
-            </p:cNvSpPr>
-            <p:nvPr/>
-          </p:nvSpPr>
-          <p:spPr>
-            <a:xfrm>
-              <a:off x="586253" y="6119980"/>
-              <a:ext cx="89812" cy="91440"/>
-            </a:xfrm>
-            <a:prstGeom prst="roundRect">
-              <a:avLst/>
-            </a:prstGeom>
-            <a:solidFill>
-              <a:srgbClr val="F16345"/>
-            </a:solidFill>
-            <a:ln>
-              <a:noFill/>
-            </a:ln>
-          </p:spPr>
-          <p:style>
-            <a:lnRef idx="2">
-              <a:schemeClr val="accent1">
-                <a:shade val="50000"/>
-              </a:schemeClr>
-            </a:lnRef>
-            <a:fillRef idx="1">
-              <a:schemeClr val="accent1"/>
-            </a:fillRef>
-            <a:effectRef idx="0">
-              <a:schemeClr val="accent1"/>
-            </a:effectRef>
-            <a:fontRef idx="minor">
-              <a:schemeClr val="lt1"/>
-            </a:fontRef>
-          </p:style>
-          <p:txBody>
-            <a:bodyPr lIns="108000" tIns="72000" rIns="108000" bIns="72000" rtlCol="0" anchor="ctr"/>
-            <a:lstStyle/>
-            <a:p>
-              <a:pPr algn="ctr"/>
-              <a:endParaRPr lang="en-GB" sz="1600" dirty="0">
-                <a:solidFill>
-                  <a:schemeClr val="bg1"/>
-                </a:solidFill>
-              </a:endParaRPr>
-            </a:p>
-          </p:txBody>
-        </p:sp>
-      </p:grpSp>
-      <p:grpSp>
-        <p:nvGrpSpPr>
-          <p:cNvPr id="10" name="Group 1033">
-            <a:extLst>
-              <a:ext uri="{FF2B5EF4-FFF2-40B4-BE49-F238E27FC236}">
-                <a16:creationId xmlns:a16="http://schemas.microsoft.com/office/drawing/2014/main" id="{AFA85250-5C32-0E74-0FD5-67E4490B30CD}"/>
-              </a:ext>
-            </a:extLst>
-          </p:cNvPr>
-          <p:cNvGrpSpPr/>
-          <p:nvPr/>
-        </p:nvGrpSpPr>
-        <p:grpSpPr>
-          <a:xfrm>
-            <a:off x="1107915" y="5907042"/>
-            <a:ext cx="331190" cy="98617"/>
-            <a:chOff x="961765" y="6117353"/>
-            <a:chExt cx="331190" cy="98617"/>
-          </a:xfrm>
-        </p:grpSpPr>
-        <p:sp>
-          <p:nvSpPr>
-            <p:cNvPr id="11" name="TextBox 1034">
-              <a:extLst>
-                <a:ext uri="{FF2B5EF4-FFF2-40B4-BE49-F238E27FC236}">
-                  <a16:creationId xmlns:a16="http://schemas.microsoft.com/office/drawing/2014/main" id="{423750AE-D097-DABA-1E9D-A5D4601C6AF2}"/>
-                </a:ext>
-              </a:extLst>
-            </p:cNvPr>
-            <p:cNvSpPr txBox="1"/>
-            <p:nvPr/>
-          </p:nvSpPr>
-          <p:spPr>
-            <a:xfrm>
-              <a:off x="1086167" y="6117353"/>
-              <a:ext cx="206788" cy="98617"/>
-            </a:xfrm>
-            <a:prstGeom prst="rect">
-              <a:avLst/>
-            </a:prstGeom>
-            <a:noFill/>
-          </p:spPr>
-          <p:txBody>
-            <a:bodyPr wrap="none" lIns="0" tIns="0" rIns="0" bIns="0" rtlCol="0" anchor="t">
-              <a:spAutoFit/>
-            </a:bodyPr>
-            <a:lstStyle/>
-            <a:p>
-              <a:pPr algn="l">
-                <a:lnSpc>
-                  <a:spcPct val="113000"/>
-                </a:lnSpc>
-              </a:pPr>
-              <a:r>
-                <a:rPr lang="en-GB" sz="800" dirty="0">
-                  <a:solidFill>
-                    <a:schemeClr val="tx2"/>
-                  </a:solidFill>
-                </a:rPr>
-                <a:t>2 stars</a:t>
-              </a:r>
-            </a:p>
-          </p:txBody>
-        </p:sp>
-        <p:sp>
-          <p:nvSpPr>
-            <p:cNvPr id="12" name="Rounded Rectangle 1035">
-              <a:extLst>
-                <a:ext uri="{FF2B5EF4-FFF2-40B4-BE49-F238E27FC236}">
-                  <a16:creationId xmlns:a16="http://schemas.microsoft.com/office/drawing/2014/main" id="{DCA5851D-1798-0A20-5A71-774836BD4F34}"/>
-                </a:ext>
-              </a:extLst>
-            </p:cNvPr>
-            <p:cNvSpPr>
-              <a:spLocks noChangeAspect="1"/>
-            </p:cNvSpPr>
-            <p:nvPr/>
-          </p:nvSpPr>
-          <p:spPr>
-            <a:xfrm>
-              <a:off x="961765" y="6120942"/>
-              <a:ext cx="89812" cy="91440"/>
-            </a:xfrm>
-            <a:prstGeom prst="roundRect">
-              <a:avLst/>
-            </a:prstGeom>
-            <a:solidFill>
-              <a:srgbClr val="F69400"/>
-            </a:solidFill>
-            <a:ln>
-              <a:noFill/>
-            </a:ln>
-          </p:spPr>
-          <p:style>
-            <a:lnRef idx="2">
-              <a:schemeClr val="accent1">
-                <a:shade val="50000"/>
-              </a:schemeClr>
-            </a:lnRef>
-            <a:fillRef idx="1">
-              <a:schemeClr val="accent1"/>
-            </a:fillRef>
-            <a:effectRef idx="0">
-              <a:schemeClr val="accent1"/>
-            </a:effectRef>
-            <a:fontRef idx="minor">
-              <a:schemeClr val="lt1"/>
-            </a:fontRef>
-          </p:style>
-          <p:txBody>
-            <a:bodyPr lIns="108000" tIns="72000" rIns="108000" bIns="72000" rtlCol="0" anchor="ctr"/>
-            <a:lstStyle/>
-            <a:p>
-              <a:pPr algn="ctr"/>
-              <a:endParaRPr lang="en-GB" sz="1600" dirty="0">
-                <a:solidFill>
-                  <a:schemeClr val="bg1"/>
-                </a:solidFill>
-              </a:endParaRPr>
-            </a:p>
-          </p:txBody>
-        </p:sp>
-      </p:grpSp>
-      <p:grpSp>
-        <p:nvGrpSpPr>
-          <p:cNvPr id="13" name="Group 1036">
-            <a:extLst>
-              <a:ext uri="{FF2B5EF4-FFF2-40B4-BE49-F238E27FC236}">
-                <a16:creationId xmlns:a16="http://schemas.microsoft.com/office/drawing/2014/main" id="{49B9D467-2411-DC5B-B05F-6F662BF677A0}"/>
-              </a:ext>
-            </a:extLst>
-          </p:cNvPr>
-          <p:cNvGrpSpPr/>
-          <p:nvPr/>
-        </p:nvGrpSpPr>
-        <p:grpSpPr>
-          <a:xfrm>
-            <a:off x="1555751" y="5907042"/>
-            <a:ext cx="331190" cy="98617"/>
-            <a:chOff x="1114165" y="6269753"/>
-            <a:chExt cx="331190" cy="98617"/>
-          </a:xfrm>
-        </p:grpSpPr>
-        <p:sp>
-          <p:nvSpPr>
-            <p:cNvPr id="14" name="TextBox 1037">
-              <a:extLst>
-                <a:ext uri="{FF2B5EF4-FFF2-40B4-BE49-F238E27FC236}">
-                  <a16:creationId xmlns:a16="http://schemas.microsoft.com/office/drawing/2014/main" id="{CC5C6A22-8797-60A5-73E8-1D1CB180F31E}"/>
-                </a:ext>
-              </a:extLst>
-            </p:cNvPr>
-            <p:cNvSpPr txBox="1"/>
-            <p:nvPr/>
-          </p:nvSpPr>
-          <p:spPr>
-            <a:xfrm>
-              <a:off x="1238567" y="6269753"/>
-              <a:ext cx="206788" cy="98617"/>
-            </a:xfrm>
-            <a:prstGeom prst="rect">
-              <a:avLst/>
-            </a:prstGeom>
-            <a:noFill/>
-          </p:spPr>
-          <p:txBody>
-            <a:bodyPr wrap="none" lIns="0" tIns="0" rIns="0" bIns="0" rtlCol="0" anchor="t">
-              <a:spAutoFit/>
-            </a:bodyPr>
-            <a:lstStyle/>
-            <a:p>
-              <a:pPr algn="l">
-                <a:lnSpc>
-                  <a:spcPct val="113000"/>
-                </a:lnSpc>
-              </a:pPr>
-              <a:r>
-                <a:rPr lang="en-GB" sz="800" dirty="0">
-                  <a:solidFill>
-                    <a:schemeClr val="tx2"/>
-                  </a:solidFill>
-                </a:rPr>
-                <a:t>3 stars</a:t>
-              </a:r>
-            </a:p>
-          </p:txBody>
-        </p:sp>
-        <p:sp>
-          <p:nvSpPr>
-            <p:cNvPr id="15" name="Rounded Rectangle 1038">
-              <a:extLst>
-                <a:ext uri="{FF2B5EF4-FFF2-40B4-BE49-F238E27FC236}">
-                  <a16:creationId xmlns:a16="http://schemas.microsoft.com/office/drawing/2014/main" id="{4AA5AD01-5458-540B-26C9-068D9EC2C1E7}"/>
-                </a:ext>
-              </a:extLst>
-            </p:cNvPr>
-            <p:cNvSpPr>
-              <a:spLocks noChangeAspect="1"/>
-            </p:cNvSpPr>
-            <p:nvPr/>
-          </p:nvSpPr>
-          <p:spPr>
-            <a:xfrm>
-              <a:off x="1114165" y="6273342"/>
-              <a:ext cx="89812" cy="91440"/>
-            </a:xfrm>
-            <a:prstGeom prst="roundRect">
-              <a:avLst/>
-            </a:prstGeom>
-            <a:solidFill>
-              <a:srgbClr val="F1C109"/>
-            </a:solidFill>
-            <a:ln>
-              <a:noFill/>
-            </a:ln>
-          </p:spPr>
-          <p:style>
-            <a:lnRef idx="2">
-              <a:schemeClr val="accent1">
-                <a:shade val="50000"/>
-              </a:schemeClr>
-            </a:lnRef>
-            <a:fillRef idx="1">
-              <a:schemeClr val="accent1"/>
-            </a:fillRef>
-            <a:effectRef idx="0">
-              <a:schemeClr val="accent1"/>
-            </a:effectRef>
-            <a:fontRef idx="minor">
-              <a:schemeClr val="lt1"/>
-            </a:fontRef>
-          </p:style>
-          <p:txBody>
-            <a:bodyPr lIns="108000" tIns="72000" rIns="108000" bIns="72000" rtlCol="0" anchor="ctr"/>
-            <a:lstStyle/>
-            <a:p>
-              <a:pPr algn="ctr"/>
-              <a:endParaRPr lang="en-GB" sz="1600" dirty="0">
-                <a:solidFill>
-                  <a:schemeClr val="bg1"/>
-                </a:solidFill>
-              </a:endParaRPr>
-            </a:p>
-          </p:txBody>
-        </p:sp>
-      </p:grpSp>
-      <p:grpSp>
-        <p:nvGrpSpPr>
-          <p:cNvPr id="16" name="Group 1039">
-            <a:extLst>
-              <a:ext uri="{FF2B5EF4-FFF2-40B4-BE49-F238E27FC236}">
-                <a16:creationId xmlns:a16="http://schemas.microsoft.com/office/drawing/2014/main" id="{494117D0-24D7-5736-0510-8FF302DE1223}"/>
-              </a:ext>
-            </a:extLst>
-          </p:cNvPr>
-          <p:cNvGrpSpPr/>
-          <p:nvPr/>
-        </p:nvGrpSpPr>
-        <p:grpSpPr>
-          <a:xfrm>
-            <a:off x="2003587" y="5907042"/>
-            <a:ext cx="331190" cy="98617"/>
-            <a:chOff x="1114165" y="6269753"/>
-            <a:chExt cx="331190" cy="98617"/>
-          </a:xfrm>
-        </p:grpSpPr>
-        <p:sp>
-          <p:nvSpPr>
-            <p:cNvPr id="17" name="TextBox 1040">
-              <a:extLst>
-                <a:ext uri="{FF2B5EF4-FFF2-40B4-BE49-F238E27FC236}">
-                  <a16:creationId xmlns:a16="http://schemas.microsoft.com/office/drawing/2014/main" id="{23408114-59B2-C1D2-8E4E-1ADA2A65B568}"/>
-                </a:ext>
-              </a:extLst>
-            </p:cNvPr>
-            <p:cNvSpPr txBox="1"/>
-            <p:nvPr/>
-          </p:nvSpPr>
-          <p:spPr>
-            <a:xfrm>
-              <a:off x="1238567" y="6269753"/>
-              <a:ext cx="206788" cy="98617"/>
-            </a:xfrm>
-            <a:prstGeom prst="rect">
-              <a:avLst/>
-            </a:prstGeom>
-            <a:noFill/>
-          </p:spPr>
-          <p:txBody>
-            <a:bodyPr wrap="none" lIns="0" tIns="0" rIns="0" bIns="0" rtlCol="0" anchor="t">
-              <a:spAutoFit/>
-            </a:bodyPr>
-            <a:lstStyle/>
-            <a:p>
-              <a:pPr algn="l">
-                <a:lnSpc>
-                  <a:spcPct val="113000"/>
-                </a:lnSpc>
-              </a:pPr>
-              <a:r>
-                <a:rPr lang="en-GB" sz="800" dirty="0">
-                  <a:solidFill>
-                    <a:schemeClr val="tx2"/>
-                  </a:solidFill>
-                </a:rPr>
-                <a:t>4 stars</a:t>
-              </a:r>
-            </a:p>
-          </p:txBody>
-        </p:sp>
-        <p:sp>
-          <p:nvSpPr>
-            <p:cNvPr id="18" name="Rounded Rectangle 1041">
-              <a:extLst>
-                <a:ext uri="{FF2B5EF4-FFF2-40B4-BE49-F238E27FC236}">
-                  <a16:creationId xmlns:a16="http://schemas.microsoft.com/office/drawing/2014/main" id="{803085FD-82BC-A32D-C289-50A1EA389CBA}"/>
-                </a:ext>
-              </a:extLst>
-            </p:cNvPr>
-            <p:cNvSpPr>
-              <a:spLocks noChangeAspect="1"/>
-            </p:cNvSpPr>
-            <p:nvPr/>
-          </p:nvSpPr>
-          <p:spPr>
-            <a:xfrm>
-              <a:off x="1114165" y="6273342"/>
-              <a:ext cx="89812" cy="91440"/>
-            </a:xfrm>
-            <a:prstGeom prst="roundRect">
-              <a:avLst/>
-            </a:prstGeom>
-            <a:solidFill>
-              <a:srgbClr val="40C360"/>
-            </a:solidFill>
-            <a:ln>
-              <a:noFill/>
-            </a:ln>
-          </p:spPr>
-          <p:style>
-            <a:lnRef idx="2">
-              <a:schemeClr val="accent1">
-                <a:shade val="50000"/>
-              </a:schemeClr>
-            </a:lnRef>
-            <a:fillRef idx="1">
-              <a:schemeClr val="accent1"/>
-            </a:fillRef>
-            <a:effectRef idx="0">
-              <a:schemeClr val="accent1"/>
-            </a:effectRef>
-            <a:fontRef idx="minor">
-              <a:schemeClr val="lt1"/>
-            </a:fontRef>
-          </p:style>
-          <p:txBody>
-            <a:bodyPr lIns="108000" tIns="72000" rIns="108000" bIns="72000" rtlCol="0" anchor="ctr"/>
-            <a:lstStyle/>
-            <a:p>
-              <a:pPr algn="ctr"/>
-              <a:endParaRPr lang="en-GB" sz="1600" dirty="0">
-                <a:solidFill>
-                  <a:schemeClr val="bg1"/>
-                </a:solidFill>
-              </a:endParaRPr>
-            </a:p>
-          </p:txBody>
-        </p:sp>
-      </p:grpSp>
-      <p:grpSp>
-        <p:nvGrpSpPr>
-          <p:cNvPr id="19" name="Group 1042">
-            <a:extLst>
-              <a:ext uri="{FF2B5EF4-FFF2-40B4-BE49-F238E27FC236}">
-                <a16:creationId xmlns:a16="http://schemas.microsoft.com/office/drawing/2014/main" id="{EA1A3B8F-2D14-50E5-CC9E-8D67204ED42F}"/>
-              </a:ext>
-            </a:extLst>
-          </p:cNvPr>
-          <p:cNvGrpSpPr/>
-          <p:nvPr/>
-        </p:nvGrpSpPr>
-        <p:grpSpPr>
-          <a:xfrm>
-            <a:off x="2451422" y="5907042"/>
-            <a:ext cx="331190" cy="98617"/>
-            <a:chOff x="1114165" y="6269753"/>
-            <a:chExt cx="331190" cy="98617"/>
-          </a:xfrm>
-        </p:grpSpPr>
-        <p:sp>
-          <p:nvSpPr>
-            <p:cNvPr id="20" name="TextBox 1043">
-              <a:extLst>
-                <a:ext uri="{FF2B5EF4-FFF2-40B4-BE49-F238E27FC236}">
-                  <a16:creationId xmlns:a16="http://schemas.microsoft.com/office/drawing/2014/main" id="{DAA04C80-6D49-A5BF-6EE7-1A1509E8E509}"/>
-                </a:ext>
-              </a:extLst>
-            </p:cNvPr>
-            <p:cNvSpPr txBox="1"/>
-            <p:nvPr/>
-          </p:nvSpPr>
-          <p:spPr>
-            <a:xfrm>
-              <a:off x="1238567" y="6269753"/>
-              <a:ext cx="206788" cy="98617"/>
-            </a:xfrm>
-            <a:prstGeom prst="rect">
-              <a:avLst/>
-            </a:prstGeom>
-            <a:noFill/>
-          </p:spPr>
-          <p:txBody>
-            <a:bodyPr wrap="none" lIns="0" tIns="0" rIns="0" bIns="0" rtlCol="0" anchor="t">
-              <a:spAutoFit/>
-            </a:bodyPr>
-            <a:lstStyle/>
-            <a:p>
-              <a:pPr algn="l">
-                <a:lnSpc>
-                  <a:spcPct val="113000"/>
-                </a:lnSpc>
-              </a:pPr>
-              <a:r>
-                <a:rPr lang="en-GB" sz="800" dirty="0">
-                  <a:solidFill>
-                    <a:schemeClr val="tx2"/>
-                  </a:solidFill>
-                </a:rPr>
-                <a:t>5 stars</a:t>
-              </a:r>
-            </a:p>
-          </p:txBody>
-        </p:sp>
-        <p:sp>
-          <p:nvSpPr>
-            <p:cNvPr id="21" name="Rounded Rectangle 1044">
-              <a:extLst>
-                <a:ext uri="{FF2B5EF4-FFF2-40B4-BE49-F238E27FC236}">
-                  <a16:creationId xmlns:a16="http://schemas.microsoft.com/office/drawing/2014/main" id="{8EDD62DD-BDAB-A371-10CA-58F3594F770D}"/>
-                </a:ext>
-              </a:extLst>
-            </p:cNvPr>
-            <p:cNvSpPr>
-              <a:spLocks noChangeAspect="1"/>
-            </p:cNvSpPr>
-            <p:nvPr/>
-          </p:nvSpPr>
-          <p:spPr>
-            <a:xfrm>
-              <a:off x="1114165" y="6273342"/>
-              <a:ext cx="89812" cy="91440"/>
-            </a:xfrm>
-            <a:prstGeom prst="roundRect">
-              <a:avLst/>
-            </a:prstGeom>
-            <a:solidFill>
-              <a:srgbClr val="008A38"/>
-            </a:solidFill>
-            <a:ln>
-              <a:noFill/>
-            </a:ln>
-          </p:spPr>
-          <p:style>
-            <a:lnRef idx="2">
-              <a:schemeClr val="accent1">
-                <a:shade val="50000"/>
-              </a:schemeClr>
-            </a:lnRef>
-            <a:fillRef idx="1">
-              <a:schemeClr val="accent1"/>
-            </a:fillRef>
-            <a:effectRef idx="0">
-              <a:schemeClr val="accent1"/>
-            </a:effectRef>
-            <a:fontRef idx="minor">
-              <a:schemeClr val="lt1"/>
-            </a:fontRef>
-          </p:style>
-          <p:txBody>
-            <a:bodyPr lIns="108000" tIns="72000" rIns="108000" bIns="72000" rtlCol="0" anchor="ctr"/>
-            <a:lstStyle/>
-            <a:p>
-              <a:pPr algn="ctr"/>
-              <a:endParaRPr lang="en-GB" sz="1600" dirty="0">
-                <a:solidFill>
-                  <a:schemeClr val="bg1"/>
-                </a:solidFill>
-              </a:endParaRPr>
-            </a:p>
-          </p:txBody>
-        </p:sp>
-      </p:grpSp>
-      <p:sp>
-        <p:nvSpPr>
-          <p:cNvPr id="22" name="Footer Placeholder 1004">
-            <a:extLst>
-              <a:ext uri="{FF2B5EF4-FFF2-40B4-BE49-F238E27FC236}">
-                <a16:creationId xmlns:a16="http://schemas.microsoft.com/office/drawing/2014/main" id="{93EAE8AB-0033-D4D9-57B7-71ECAF7ABC62}"/>
-              </a:ext>
-            </a:extLst>
-          </p:cNvPr>
-          <p:cNvSpPr>
-            <a:spLocks noGrp="1"/>
-          </p:cNvSpPr>
-          <p:nvPr>
-            <p:ph type="ftr" sz="quarter" idx="3"/>
-          </p:nvPr>
-        </p:nvSpPr>
-        <p:spPr>
-          <a:xfrm>
-            <a:off x="192088" y="6392596"/>
-            <a:ext cx="1763922" cy="370422"/>
-          </a:xfrm>
-        </p:spPr>
-        <p:txBody>
-          <a:bodyPr/>
-          <a:lstStyle/>
-          <a:p>
-            <a:r>
-              <a:rPr lang="en-US" dirty="0"/>
-              <a:t>Generated with Sigrid</a:t>
-            </a:r>
-          </a:p>
-          <a:p>
-            <a:r>
-              <a:rPr lang="en-US" dirty="0"/>
-              <a:t>for CUSTOMER_NAME</a:t>
-            </a:r>
-          </a:p>
-        </p:txBody>
-      </p:sp>
-    </p:spTree>
-    <p:extLst>
-      <p:ext uri="{BB962C8B-B14F-4D97-AF65-F5344CB8AC3E}">
-        <p14:creationId xmlns:p14="http://schemas.microsoft.com/office/powerpoint/2010/main" val="1935461179"/>
-      </p:ext>
-    </p:extLst>
-  </p:cSld>
-  <p:clrMapOvr>
-    <a:masterClrMapping/>
-  </p:clrMapOvr>
-</p:sld>
-</file>
-
 <file path=ppt/slides/slide5.xml><?xml version="1.0" encoding="utf-8"?>
 <p:sld xmlns:a="http://schemas.openxmlformats.org/drawingml/2006/main" xmlns:r="http://schemas.openxmlformats.org/officeDocument/2006/relationships" xmlns:p="http://schemas.openxmlformats.org/presentationml/2006/main">
   <p:cSld>

</xml_diff>

<commit_message>
Update placeholders to support group-by parameter
</commit_message>
<xml_diff>
--- a/src/report_generator/presets/templates/portfolio-metrics.pptx
+++ b/src/report_generator/presets/templates/portfolio-metrics.pptx
@@ -17496,7 +17496,7 @@
                   <a:schemeClr val="bg1"/>
                 </a:solidFill>
               </a:rPr>
-              <a:t>PORTFOLIO_PERIOD_MAINT_UNIT_INTERFACING_CHANGE_GROUPED_BY_TEAM</a:t>
+              <a:t>PORTFOLIO_PERIOD_MAINT_UNIT_INTERFACING_CHANGE</a:t>
             </a:r>
           </a:p>
         </p:txBody>
@@ -17915,7 +17915,7 @@
                   <a:schemeClr val="tx2"/>
                 </a:solidFill>
               </a:rPr>
-              <a:t>Team</a:t>
+              <a:t>GROUPED_BY_LABEL</a:t>
             </a:r>
           </a:p>
         </p:txBody>
@@ -18203,7 +18203,7 @@
                   <a:schemeClr val="bg1"/>
                 </a:solidFill>
               </a:rPr>
-              <a:t>PORTFOLIO_PERIOD_MAINT_MODULE_COUPLING_GROUPED_BY_TEAM</a:t>
+              <a:t>PORTFOLIO_PERIOD_MAINT_MODULE_COUPLING</a:t>
             </a:r>
           </a:p>
         </p:txBody>
@@ -18807,7 +18807,7 @@
                   <a:schemeClr val="tx2"/>
                 </a:solidFill>
               </a:rPr>
-              <a:t>Team</a:t>
+              <a:t>GROUPED_BY_LABEL</a:t>
             </a:r>
           </a:p>
         </p:txBody>
@@ -19159,7 +19159,7 @@
                   <a:schemeClr val="bg1"/>
                 </a:solidFill>
               </a:rPr>
-              <a:t>PORTFOLIO_PERIOD_MAINT_MODULE_COUPLING_CHANGE_GROUPED_BY_TEAM</a:t>
+              <a:t>PORTFOLIO_PERIOD_MAINT_MODULE_COUPLING_CHANGE</a:t>
             </a:r>
           </a:p>
         </p:txBody>
@@ -19578,7 +19578,7 @@
                   <a:schemeClr val="tx2"/>
                 </a:solidFill>
               </a:rPr>
-              <a:t>Team</a:t>
+              <a:t>GROUPED_BY_LABEL</a:t>
             </a:r>
           </a:p>
         </p:txBody>
@@ -19866,7 +19866,7 @@
                   <a:schemeClr val="bg1"/>
                 </a:solidFill>
               </a:rPr>
-              <a:t>PORTFOLIO_PERIOD_MAINT_COMPONENT_INDEPENDENCE_GROUPED_BY_TEAM</a:t>
+              <a:t>PORTFOLIO_PERIOD_MAINT_COMPONENT_INDEPENDENCE</a:t>
             </a:r>
           </a:p>
         </p:txBody>
@@ -20470,7 +20470,7 @@
                   <a:schemeClr val="tx2"/>
                 </a:solidFill>
               </a:rPr>
-              <a:t>Team</a:t>
+              <a:t>GROUPED_BY_LABEL</a:t>
             </a:r>
           </a:p>
         </p:txBody>
@@ -20822,7 +20822,7 @@
                   <a:schemeClr val="bg1"/>
                 </a:solidFill>
               </a:rPr>
-              <a:t>PORTFOLIO_PERIOD_MAINT_COMPONENT_INDEPENDENCE_CHANGE_GROUPED_BY_TEAM</a:t>
+              <a:t>PORTFOLIO_PERIOD_MAINT_COMPONENT_INDEPENDENCE_CHANGE</a:t>
             </a:r>
           </a:p>
         </p:txBody>
@@ -21241,7 +21241,7 @@
                   <a:schemeClr val="tx2"/>
                 </a:solidFill>
               </a:rPr>
-              <a:t>Team</a:t>
+              <a:t>GROUPED_BY_LABEL</a:t>
             </a:r>
           </a:p>
         </p:txBody>
@@ -21529,7 +21529,7 @@
                   <a:schemeClr val="bg1"/>
                 </a:solidFill>
               </a:rPr>
-              <a:t>PORTFOLIO_PERIOD_MAINT_COMPONENT_ENTANGLEMENT_GROUPED_BY_TEAM</a:t>
+              <a:t>PORTFOLIO_PERIOD_MAINT_COMPONENT_ENTANGLEMENT</a:t>
             </a:r>
           </a:p>
         </p:txBody>
@@ -22133,7 +22133,7 @@
                   <a:schemeClr val="tx2"/>
                 </a:solidFill>
               </a:rPr>
-              <a:t>Team</a:t>
+              <a:t>GROUPED_BY_LABEL</a:t>
             </a:r>
           </a:p>
         </p:txBody>
@@ -22485,7 +22485,7 @@
                   <a:schemeClr val="bg1"/>
                 </a:solidFill>
               </a:rPr>
-              <a:t>PORTFOLIO_PERIOD_MAINT_COMPONENT_ENTANGLEMENT_CHANGE_GROUPED_BY_TEAM</a:t>
+              <a:t>PORTFOLIO_PERIOD_MAINT_COMPONENT_ENTANGLEMENT_CHANGE</a:t>
             </a:r>
           </a:p>
         </p:txBody>
@@ -22904,7 +22904,7 @@
                   <a:schemeClr val="tx2"/>
                 </a:solidFill>
               </a:rPr>
-              <a:t>Team</a:t>
+              <a:t>GROUPED_BY_LABEL</a:t>
             </a:r>
           </a:p>
         </p:txBody>
@@ -23460,7 +23460,7 @@
                   <a:schemeClr val="bg1"/>
                 </a:solidFill>
               </a:rPr>
-              <a:t>PORTFOLIO_PERIOD_ARCH_CODE_BREAKDOWN_GROUPED_BY_TEAM</a:t>
+              <a:t>PORTFOLIO_PERIOD_ARCH_CODE_BREAKDOWN</a:t>
             </a:r>
           </a:p>
         </p:txBody>
@@ -24064,7 +24064,7 @@
                   <a:schemeClr val="tx2"/>
                 </a:solidFill>
               </a:rPr>
-              <a:t>Team</a:t>
+              <a:t>GROUPED_BY_LABEL</a:t>
             </a:r>
           </a:p>
         </p:txBody>
@@ -24416,7 +24416,7 @@
                   <a:schemeClr val="bg1"/>
                 </a:solidFill>
               </a:rPr>
-              <a:t>PORTFOLIO_PERIOD_ARCH_CODE_BREAKDOWN_RATINGS_CHANGE_GROUPED_BY_TEAM</a:t>
+              <a:t>PORTFOLIO_PERIOD_ARCH_CODE_BREAKDOWN_RATINGS_CHANGE</a:t>
             </a:r>
           </a:p>
         </p:txBody>
@@ -24835,7 +24835,7 @@
                   <a:schemeClr val="tx2"/>
                 </a:solidFill>
               </a:rPr>
-              <a:t>Team</a:t>
+              <a:t>GROUPED_BY_LABEL</a:t>
             </a:r>
           </a:p>
         </p:txBody>
@@ -25385,7 +25385,7 @@
                   <a:schemeClr val="bg1"/>
                 </a:solidFill>
               </a:rPr>
-              <a:t>PORTFOLIO_PERIOD_ARCH_COMPONENT_COUPLING_GROUPED_BY_TEAM</a:t>
+              <a:t>PORTFOLIO_PERIOD_ARCH_COMPONENT_COUPLING</a:t>
             </a:r>
           </a:p>
         </p:txBody>
@@ -25989,7 +25989,7 @@
                   <a:schemeClr val="tx2"/>
                 </a:solidFill>
               </a:rPr>
-              <a:t>Team</a:t>
+              <a:t>GROUPED_BY_LABEL</a:t>
             </a:r>
           </a:p>
         </p:txBody>
@@ -26341,7 +26341,7 @@
                   <a:schemeClr val="bg1"/>
                 </a:solidFill>
               </a:rPr>
-              <a:t>PORTFOLIO_PERIOD_ARCH_COMPONENT_COUPLING_RATINGS_CHANGE_GROUPED_BY_TEAM</a:t>
+              <a:t>PORTFOLIO_PERIOD_ARCH_COMPONENT_COUPLING_RATINGS_CHANGE</a:t>
             </a:r>
           </a:p>
         </p:txBody>
@@ -26760,7 +26760,7 @@
                   <a:schemeClr val="tx2"/>
                 </a:solidFill>
               </a:rPr>
-              <a:t>Team</a:t>
+              <a:t>GROUPED_BY_LABEL</a:t>
             </a:r>
           </a:p>
         </p:txBody>
@@ -27048,7 +27048,7 @@
                   <a:schemeClr val="bg1"/>
                 </a:solidFill>
               </a:rPr>
-              <a:t>PORTFOLIO_PERIOD_ARCH_COMPONENT_ADJACENCY_GROUPED_BY_TEAM</a:t>
+              <a:t>PORTFOLIO_PERIOD_ARCH_COMPONENT_ADJACENCY</a:t>
             </a:r>
           </a:p>
         </p:txBody>
@@ -27652,7 +27652,7 @@
                   <a:schemeClr val="tx2"/>
                 </a:solidFill>
               </a:rPr>
-              <a:t>Team</a:t>
+              <a:t>GROUPED_BY_LABEL</a:t>
             </a:r>
           </a:p>
         </p:txBody>
@@ -28004,7 +28004,7 @@
                   <a:schemeClr val="bg1"/>
                 </a:solidFill>
               </a:rPr>
-              <a:t>PORTFOLIO_PERIOD_ARCH_COMPONENT_ADJACENCY_RATINGS_CHANGE_GROUPED_BY_TEAM</a:t>
+              <a:t>PORTFOLIO_PERIOD_ARCH_COMPONENT_ADJACENCY_RATINGS_CHANGE</a:t>
             </a:r>
           </a:p>
         </p:txBody>
@@ -28423,7 +28423,7 @@
                   <a:schemeClr val="tx2"/>
                 </a:solidFill>
               </a:rPr>
-              <a:t>Team</a:t>
+              <a:t>GROUPED_BY_LABEL</a:t>
             </a:r>
           </a:p>
         </p:txBody>
@@ -28711,7 +28711,7 @@
                   <a:schemeClr val="bg1"/>
                 </a:solidFill>
               </a:rPr>
-              <a:t>PORTFOLIO_PERIOD_ARCH_COMPONENT_COHESION_GROUPED_BY_TEAM</a:t>
+              <a:t>PORTFOLIO_PERIOD_ARCH_COMPONENT_COHESION</a:t>
             </a:r>
           </a:p>
         </p:txBody>
@@ -29315,7 +29315,7 @@
                   <a:schemeClr val="tx2"/>
                 </a:solidFill>
               </a:rPr>
-              <a:t>Team</a:t>
+              <a:t>GROUPED_BY_LABEL</a:t>
             </a:r>
           </a:p>
         </p:txBody>
@@ -29667,7 +29667,7 @@
                   <a:schemeClr val="bg1"/>
                 </a:solidFill>
               </a:rPr>
-              <a:t>PORTFOLIO_PERIOD_ARCH_COMPONENT_COHESION_RATINGS_CHANGE_GROUPED_BY_TEAM</a:t>
+              <a:t>PORTFOLIO_PERIOD_ARCH_COMPONENT_COHESION_RATINGS_CHANGE</a:t>
             </a:r>
           </a:p>
         </p:txBody>
@@ -30086,7 +30086,7 @@
                   <a:schemeClr val="tx2"/>
                 </a:solidFill>
               </a:rPr>
-              <a:t>Team</a:t>
+              <a:t>GROUPED_BY_LABEL</a:t>
             </a:r>
           </a:p>
         </p:txBody>
@@ -30400,7 +30400,7 @@
                   <a:schemeClr val="bg1"/>
                 </a:solidFill>
               </a:rPr>
-              <a:t>_GROUPED_BY_TEAM</a:t>
+              <a:t/>
             </a:r>
           </a:p>
         </p:txBody>
@@ -31004,7 +31004,7 @@
                   <a:schemeClr val="tx2"/>
                 </a:solidFill>
               </a:rPr>
-              <a:t>Team</a:t>
+              <a:t>GROUPED_BY_LABEL</a:t>
             </a:r>
           </a:p>
         </p:txBody>
@@ -31391,7 +31391,7 @@
                   <a:schemeClr val="bg1"/>
                 </a:solidFill>
               </a:rPr>
-              <a:t>PORTFOLIO_PERIOD_ARCH_COMMUNICATION_CENTRALIZATION_RATINGS_CHANGE_GROUPED_BY_TEAM</a:t>
+              <a:t>PORTFOLIO_PERIOD_ARCH_COMMUNICATION_CENTRALIZATION_RATINGS_CHANGE</a:t>
             </a:r>
           </a:p>
         </p:txBody>
@@ -31810,7 +31810,7 @@
                   <a:schemeClr val="tx2"/>
                 </a:solidFill>
               </a:rPr>
-              <a:t>Team</a:t>
+              <a:t>GROUPED_BY_LABEL</a:t>
             </a:r>
           </a:p>
         </p:txBody>
@@ -32098,7 +32098,7 @@
                   <a:schemeClr val="bg1"/>
                 </a:solidFill>
               </a:rPr>
-              <a:t>PORTFOLIO_PERIOD_ARCH_DATA_COUPLING_GROUPED_BY_TEAM</a:t>
+              <a:t>PORTFOLIO_PERIOD_ARCH_DATA_COUPLING</a:t>
             </a:r>
           </a:p>
         </p:txBody>
@@ -32702,7 +32702,7 @@
                   <a:schemeClr val="tx2"/>
                 </a:solidFill>
               </a:rPr>
-              <a:t>Team</a:t>
+              <a:t>GROUPED_BY_LABEL</a:t>
             </a:r>
           </a:p>
         </p:txBody>
@@ -33054,7 +33054,7 @@
                   <a:schemeClr val="bg1"/>
                 </a:solidFill>
               </a:rPr>
-              <a:t>PORTFOLIO_PERIOD_ARCH_DATA_COUPLING_RATINGS_CHANGE_GROUPED_BY_TEAM</a:t>
+              <a:t>PORTFOLIO_PERIOD_ARCH_DATA_COUPLING_RATINGS_CHANGE</a:t>
             </a:r>
           </a:p>
         </p:txBody>
@@ -33473,7 +33473,7 @@
                   <a:schemeClr val="tx2"/>
                 </a:solidFill>
               </a:rPr>
-              <a:t>Team</a:t>
+              <a:t>GROUPED_BY_LABEL</a:t>
             </a:r>
           </a:p>
         </p:txBody>
@@ -33680,7 +33680,7 @@
                   <a:schemeClr val="bg1"/>
                 </a:solidFill>
               </a:rPr>
-              <a:t>PORTFOLIO_PERIOD_MAINT_DUPLICATION_GROUPED_BY_TEAM</a:t>
+              <a:t>PORTFOLIO_PERIOD_MAINT_DUPLICATION</a:t>
             </a:r>
           </a:p>
         </p:txBody>
@@ -34284,7 +34284,7 @@
                   <a:schemeClr val="tx2"/>
                 </a:solidFill>
               </a:rPr>
-              <a:t>Team</a:t>
+              <a:t>GROUPED_BY_LABEL</a:t>
             </a:r>
           </a:p>
         </p:txBody>
@@ -34636,7 +34636,7 @@
                   <a:schemeClr val="bg1"/>
                 </a:solidFill>
               </a:rPr>
-              <a:t>PORTFOLIO_PERIOD_ARCH_BOUNDED_EVOLUTION_GROUPED_BY_TEAM</a:t>
+              <a:t>PORTFOLIO_PERIOD_ARCH_BOUNDED_EVOLUTION</a:t>
             </a:r>
           </a:p>
         </p:txBody>
@@ -35240,7 +35240,7 @@
                   <a:schemeClr val="tx2"/>
                 </a:solidFill>
               </a:rPr>
-              <a:t>Team</a:t>
+              <a:t>GROUPED_BY_LABEL</a:t>
             </a:r>
           </a:p>
         </p:txBody>
@@ -35592,7 +35592,7 @@
                   <a:schemeClr val="bg1"/>
                 </a:solidFill>
               </a:rPr>
-              <a:t>PORTFOLIO_PERIOD_ARCH_BOUNDED_EVOLUTION_RATINGS_CHANGE_GROUPED_BY_TEAM</a:t>
+              <a:t>PORTFOLIO_PERIOD_ARCH_BOUNDED_EVOLUTION_RATINGS_CHANGE</a:t>
             </a:r>
           </a:p>
         </p:txBody>
@@ -36011,7 +36011,7 @@
                   <a:schemeClr val="tx2"/>
                 </a:solidFill>
               </a:rPr>
-              <a:t>Team</a:t>
+              <a:t>GROUPED_BY_LABEL</a:t>
             </a:r>
           </a:p>
         </p:txBody>
@@ -36299,7 +36299,7 @@
                   <a:schemeClr val="bg1"/>
                 </a:solidFill>
               </a:rPr>
-              <a:t>PORTFOLIO_PERIOD_ARCH_KNOWLEDGE_AWARENESS_GROUPED_BY_TEAM</a:t>
+              <a:t>PORTFOLIO_PERIOD_ARCH_KNOWLEDGE_AWARENESS</a:t>
             </a:r>
           </a:p>
         </p:txBody>
@@ -36903,7 +36903,7 @@
                   <a:schemeClr val="tx2"/>
                 </a:solidFill>
               </a:rPr>
-              <a:t>Team</a:t>
+              <a:t>GROUPED_BY_LABEL</a:t>
             </a:r>
           </a:p>
         </p:txBody>
@@ -37255,7 +37255,7 @@
                   <a:schemeClr val="bg1"/>
                 </a:solidFill>
               </a:rPr>
-              <a:t>PORTFOLIO_PERIOD_ARCH_KNOWLEDGE_AWARENESS_RATINGS_CHANGE_GROUPED_BY_TEAM</a:t>
+              <a:t>PORTFOLIO_PERIOD_ARCH_KNOWLEDGE_AWARENESS_RATINGS_CHANGE</a:t>
             </a:r>
           </a:p>
         </p:txBody>
@@ -37674,7 +37674,7 @@
                   <a:schemeClr val="tx2"/>
                 </a:solidFill>
               </a:rPr>
-              <a:t>Team</a:t>
+              <a:t>GROUPED_BY_LABEL</a:t>
             </a:r>
           </a:p>
         </p:txBody>
@@ -37962,7 +37962,7 @@
                   <a:schemeClr val="bg1"/>
                 </a:solidFill>
               </a:rPr>
-              <a:t>PORTFOLIO_PERIOD_ARCH_COMPONENT_FRESHNESS_GROUPED_BY_TEAM</a:t>
+              <a:t>PORTFOLIO_PERIOD_ARCH_COMPONENT_FRESHNESS</a:t>
             </a:r>
           </a:p>
         </p:txBody>
@@ -38566,7 +38566,7 @@
                   <a:schemeClr val="tx2"/>
                 </a:solidFill>
               </a:rPr>
-              <a:t>Team</a:t>
+              <a:t>GROUPED_BY_LABEL</a:t>
             </a:r>
           </a:p>
         </p:txBody>
@@ -38918,7 +38918,7 @@
                   <a:schemeClr val="bg1"/>
                 </a:solidFill>
               </a:rPr>
-              <a:t>PORTFOLIO_PERIOD_ARCH_COMPONENT_FRESHNESS_RATINGS_CHANGE_GROUPED_BY_TEAM</a:t>
+              <a:t>PORTFOLIO_PERIOD_ARCH_COMPONENT_FRESHNESS_RATINGS_CHANGE</a:t>
             </a:r>
           </a:p>
         </p:txBody>
@@ -39337,7 +39337,7 @@
                   <a:schemeClr val="tx2"/>
                 </a:solidFill>
               </a:rPr>
-              <a:t>Team</a:t>
+              <a:t>GROUPED_BY_LABEL</a:t>
             </a:r>
           </a:p>
         </p:txBody>
@@ -39625,7 +39625,7 @@
                   <a:schemeClr val="bg1"/>
                 </a:solidFill>
               </a:rPr>
-              <a:t>PORTFOLIO_PERIOD_ARCH_TEAM_STABILITY_GROUPED_BY_TEAM</a:t>
+              <a:t>PORTFOLIO_PERIOD_ARCH_TEAM_STABILITY</a:t>
             </a:r>
           </a:p>
         </p:txBody>
@@ -40229,7 +40229,7 @@
                   <a:schemeClr val="tx2"/>
                 </a:solidFill>
               </a:rPr>
-              <a:t>Team</a:t>
+              <a:t>GROUPED_BY_LABEL</a:t>
             </a:r>
           </a:p>
         </p:txBody>
@@ -40581,7 +40581,7 @@
                   <a:schemeClr val="bg1"/>
                 </a:solidFill>
               </a:rPr>
-              <a:t>PORTFOLIO_PERIOD_ARCH_TEAM_STABILITY_RATINGS_CHANGE_GROUPED_BY_TEAM</a:t>
+              <a:t>PORTFOLIO_PERIOD_ARCH_TEAM_STABILITY_RATINGS_CHANGE</a:t>
             </a:r>
           </a:p>
         </p:txBody>
@@ -41000,7 +41000,7 @@
                   <a:schemeClr val="tx2"/>
                 </a:solidFill>
               </a:rPr>
-              <a:t>Team</a:t>
+              <a:t>GROUPED_BY_LABEL</a:t>
             </a:r>
           </a:p>
         </p:txBody>
@@ -41556,7 +41556,7 @@
                   <a:schemeClr val="bg1"/>
                 </a:solidFill>
               </a:rPr>
-              <a:t>PORTFOLIO_PERIOD_OSH_VULNERABILITY_GROUPED_BY_TEAM</a:t>
+              <a:t>PORTFOLIO_PERIOD_OSH_VULNERABILITY</a:t>
             </a:r>
           </a:p>
         </p:txBody>
@@ -42160,7 +42160,7 @@
                   <a:schemeClr val="tx2"/>
                 </a:solidFill>
               </a:rPr>
-              <a:t>Team</a:t>
+              <a:t>GROUPED_BY_LABEL</a:t>
             </a:r>
           </a:p>
         </p:txBody>
@@ -42512,7 +42512,7 @@
                   <a:schemeClr val="bg1"/>
                 </a:solidFill>
               </a:rPr>
-              <a:t>PORTFOLIO_PERIOD_MAINT_DUPLICATION_CHANGE_GROUPED_BY_TEAM</a:t>
+              <a:t>PORTFOLIO_PERIOD_MAINT_DUPLICATION_CHANGE</a:t>
             </a:r>
           </a:p>
         </p:txBody>
@@ -42931,7 +42931,7 @@
                   <a:schemeClr val="tx2"/>
                 </a:solidFill>
               </a:rPr>
-              <a:t>Team</a:t>
+              <a:t>GROUPED_BY_LABEL</a:t>
             </a:r>
           </a:p>
         </p:txBody>
@@ -43219,7 +43219,7 @@
                   <a:schemeClr val="bg1"/>
                 </a:solidFill>
               </a:rPr>
-              <a:t>PORTFOLIO_PERIOD_OSH_LICENSES_GROUPED_BY_TEAM</a:t>
+              <a:t>PORTFOLIO_PERIOD_OSH_LICENSES</a:t>
             </a:r>
           </a:p>
         </p:txBody>
@@ -43823,7 +43823,7 @@
                   <a:schemeClr val="tx2"/>
                 </a:solidFill>
               </a:rPr>
-              <a:t>Team</a:t>
+              <a:t>GROUPED_BY_LABEL</a:t>
             </a:r>
           </a:p>
         </p:txBody>
@@ -44175,7 +44175,7 @@
                   <a:schemeClr val="bg1"/>
                 </a:solidFill>
               </a:rPr>
-              <a:t>PORTFOLIO_PERIOD_OSH_FRESHNESS_GROUPED_BY_TEAM</a:t>
+              <a:t>PORTFOLIO_PERIOD_OSH_FRESHNESS</a:t>
             </a:r>
           </a:p>
         </p:txBody>
@@ -44779,7 +44779,7 @@
                   <a:schemeClr val="tx2"/>
                 </a:solidFill>
               </a:rPr>
-              <a:t>Team</a:t>
+              <a:t>GROUPED_BY_LABEL</a:t>
             </a:r>
           </a:p>
         </p:txBody>
@@ -45131,7 +45131,7 @@
                   <a:schemeClr val="bg1"/>
                 </a:solidFill>
               </a:rPr>
-              <a:t>PORTFOLIO_PERIOD_OSH_MANAGEMENT_GROUPED_BY_TEAM</a:t>
+              <a:t>PORTFOLIO_PERIOD_OSH_MANAGEMENT</a:t>
             </a:r>
           </a:p>
         </p:txBody>
@@ -45735,7 +45735,7 @@
                   <a:schemeClr val="tx2"/>
                 </a:solidFill>
               </a:rPr>
-              <a:t>Team</a:t>
+              <a:t>GROUPED_BY_LABEL</a:t>
             </a:r>
           </a:p>
         </p:txBody>
@@ -46087,7 +46087,7 @@
                   <a:schemeClr val="bg1"/>
                 </a:solidFill>
               </a:rPr>
-              <a:t>PORTFOLIO_PERIOD_OSH_ACTIVITY_GROUPED_BY_TEAM</a:t>
+              <a:t>PORTFOLIO_PERIOD_OSH_ACTIVITY</a:t>
             </a:r>
           </a:p>
         </p:txBody>
@@ -46133,7 +46133,7 @@
                   <a:schemeClr val="tx2"/>
                 </a:solidFill>
               </a:rPr>
-              <a:t>Team</a:t>
+              <a:t>GROUPED_BY_LABEL</a:t>
             </a:r>
           </a:p>
         </p:txBody>
@@ -47139,7 +47139,7 @@
                   <a:schemeClr val="bg1"/>
                 </a:solidFill>
               </a:rPr>
-              <a:t>PORTFOLIO_PERIOD_MAINT_UNIT_SIZE_GROUPED_BY_TEAM</a:t>
+              <a:t>PORTFOLIO_PERIOD_MAINT_UNIT_SIZE</a:t>
             </a:r>
           </a:p>
         </p:txBody>
@@ -47743,7 +47743,7 @@
                   <a:schemeClr val="tx2"/>
                 </a:solidFill>
               </a:rPr>
-              <a:t>Team</a:t>
+              <a:t>GROUPED_BY_LABEL</a:t>
             </a:r>
           </a:p>
         </p:txBody>
@@ -48095,7 +48095,7 @@
                   <a:schemeClr val="bg1"/>
                 </a:solidFill>
               </a:rPr>
-              <a:t>PORTFOLIO_PERIOD_MAINT_UNIT_SIZE_CHANGE_GROUPED_BY_TEAM</a:t>
+              <a:t>PORTFOLIO_PERIOD_MAINT_UNIT_SIZE_CHANGE</a:t>
             </a:r>
           </a:p>
         </p:txBody>
@@ -48514,7 +48514,7 @@
                   <a:schemeClr val="tx2"/>
                 </a:solidFill>
               </a:rPr>
-              <a:t>Team</a:t>
+              <a:t>GROUPED_BY_LABEL</a:t>
             </a:r>
           </a:p>
         </p:txBody>
@@ -48802,7 +48802,7 @@
                   <a:schemeClr val="bg1"/>
                 </a:solidFill>
               </a:rPr>
-              <a:t>PORTFOLIO_PERIOD_MAINT_UNIT_COMPLEXITY_GROUPED_BY_TEAM</a:t>
+              <a:t>PORTFOLIO_PERIOD_MAINT_UNIT_COMPLEXITY</a:t>
             </a:r>
           </a:p>
         </p:txBody>
@@ -49406,7 +49406,7 @@
                   <a:schemeClr val="tx2"/>
                 </a:solidFill>
               </a:rPr>
-              <a:t>Team</a:t>
+              <a:t>GROUPED_BY_LABEL</a:t>
             </a:r>
           </a:p>
         </p:txBody>
@@ -49758,7 +49758,7 @@
                   <a:schemeClr val="bg1"/>
                 </a:solidFill>
               </a:rPr>
-              <a:t>PORTFOLIO_PERIOD_MAINT_UNIT_COMPLEXITY_CHANGE_GROUPED_BY_TEAM</a:t>
+              <a:t>PORTFOLIO_PERIOD_MAINT_UNIT_COMPLEXITY_CHANGE</a:t>
             </a:r>
           </a:p>
         </p:txBody>
@@ -50177,7 +50177,7 @@
                   <a:schemeClr val="tx2"/>
                 </a:solidFill>
               </a:rPr>
-              <a:t>Team</a:t>
+              <a:t>GROUPED_BY_LABEL</a:t>
             </a:r>
           </a:p>
         </p:txBody>
@@ -50465,7 +50465,7 @@
                   <a:schemeClr val="bg1"/>
                 </a:solidFill>
               </a:rPr>
-              <a:t>PORTFOLIO_PERIOD_MAINT_UNIT_INTERFACING_GROUPED_BY_TEAM</a:t>
+              <a:t>PORTFOLIO_PERIOD_MAINT_UNIT_INTERFACING</a:t>
             </a:r>
           </a:p>
         </p:txBody>
@@ -51069,7 +51069,7 @@
                   <a:schemeClr val="tx2"/>
                 </a:solidFill>
               </a:rPr>
-              <a:t>Team</a:t>
+              <a:t>GROUPED_BY_LABEL</a:t>
             </a:r>
           </a:p>
         </p:txBody>

</xml_diff>

<commit_message>
Add groupby parameter for treemaps (#72)
* Add grouping option and combine it with filter info

* Add grouped_by placeholder

* Add group-by option to cli

* Implement grouped-by cli logic

* Update placeholders to support group-by parameter

* Ruff was mad at me

* Simplify grouping by just using the parameter option

* Don't show 'Unset' grouping header if no metadata was set

* Bump version

* Simplify dependencies

* Use portfolio_metadata.DEFAULT_GROUP_BY as CLI default instead of duplicating "team"

* Normalize grouping dimension case inside _dimension_from_parameter

Every call site was appending .lower() to _dimension_from_parameter's result
(and one had forgotten to). Move the normalization into the method itself so
callers can't get it wrong.

* Move grouping logic to placeholders.context

* Rename portfolio_metadata back to portfolio_filters

* Update filter label name and fix imports

* Fix a few more imports

* Some more broken imports
</commit_message>
<xml_diff>
--- a/src/report_generator/presets/templates/portfolio-metrics.pptx
+++ b/src/report_generator/presets/templates/portfolio-metrics.pptx
@@ -17496,7 +17496,7 @@
                   <a:schemeClr val="bg1"/>
                 </a:solidFill>
               </a:rPr>
-              <a:t>PORTFOLIO_PERIOD_MAINT_UNIT_INTERFACING_CHANGE_GROUPED_BY_TEAM</a:t>
+              <a:t>PORTFOLIO_PERIOD_MAINT_UNIT_INTERFACING_CHANGE</a:t>
             </a:r>
           </a:p>
         </p:txBody>
@@ -17915,7 +17915,7 @@
                   <a:schemeClr val="tx2"/>
                 </a:solidFill>
               </a:rPr>
-              <a:t>Team</a:t>
+              <a:t>GROUPED_BY_LABEL</a:t>
             </a:r>
           </a:p>
         </p:txBody>
@@ -18203,7 +18203,7 @@
                   <a:schemeClr val="bg1"/>
                 </a:solidFill>
               </a:rPr>
-              <a:t>PORTFOLIO_PERIOD_MAINT_MODULE_COUPLING_GROUPED_BY_TEAM</a:t>
+              <a:t>PORTFOLIO_PERIOD_MAINT_MODULE_COUPLING</a:t>
             </a:r>
           </a:p>
         </p:txBody>
@@ -18807,7 +18807,7 @@
                   <a:schemeClr val="tx2"/>
                 </a:solidFill>
               </a:rPr>
-              <a:t>Team</a:t>
+              <a:t>GROUPED_BY_LABEL</a:t>
             </a:r>
           </a:p>
         </p:txBody>
@@ -19159,7 +19159,7 @@
                   <a:schemeClr val="bg1"/>
                 </a:solidFill>
               </a:rPr>
-              <a:t>PORTFOLIO_PERIOD_MAINT_MODULE_COUPLING_CHANGE_GROUPED_BY_TEAM</a:t>
+              <a:t>PORTFOLIO_PERIOD_MAINT_MODULE_COUPLING_CHANGE</a:t>
             </a:r>
           </a:p>
         </p:txBody>
@@ -19578,7 +19578,7 @@
                   <a:schemeClr val="tx2"/>
                 </a:solidFill>
               </a:rPr>
-              <a:t>Team</a:t>
+              <a:t>GROUPED_BY_LABEL</a:t>
             </a:r>
           </a:p>
         </p:txBody>
@@ -19866,7 +19866,7 @@
                   <a:schemeClr val="bg1"/>
                 </a:solidFill>
               </a:rPr>
-              <a:t>PORTFOLIO_PERIOD_MAINT_COMPONENT_INDEPENDENCE_GROUPED_BY_TEAM</a:t>
+              <a:t>PORTFOLIO_PERIOD_MAINT_COMPONENT_INDEPENDENCE</a:t>
             </a:r>
           </a:p>
         </p:txBody>
@@ -20470,7 +20470,7 @@
                   <a:schemeClr val="tx2"/>
                 </a:solidFill>
               </a:rPr>
-              <a:t>Team</a:t>
+              <a:t>GROUPED_BY_LABEL</a:t>
             </a:r>
           </a:p>
         </p:txBody>
@@ -20822,7 +20822,7 @@
                   <a:schemeClr val="bg1"/>
                 </a:solidFill>
               </a:rPr>
-              <a:t>PORTFOLIO_PERIOD_MAINT_COMPONENT_INDEPENDENCE_CHANGE_GROUPED_BY_TEAM</a:t>
+              <a:t>PORTFOLIO_PERIOD_MAINT_COMPONENT_INDEPENDENCE_CHANGE</a:t>
             </a:r>
           </a:p>
         </p:txBody>
@@ -21241,7 +21241,7 @@
                   <a:schemeClr val="tx2"/>
                 </a:solidFill>
               </a:rPr>
-              <a:t>Team</a:t>
+              <a:t>GROUPED_BY_LABEL</a:t>
             </a:r>
           </a:p>
         </p:txBody>
@@ -21529,7 +21529,7 @@
                   <a:schemeClr val="bg1"/>
                 </a:solidFill>
               </a:rPr>
-              <a:t>PORTFOLIO_PERIOD_MAINT_COMPONENT_ENTANGLEMENT_GROUPED_BY_TEAM</a:t>
+              <a:t>PORTFOLIO_PERIOD_MAINT_COMPONENT_ENTANGLEMENT</a:t>
             </a:r>
           </a:p>
         </p:txBody>
@@ -22133,7 +22133,7 @@
                   <a:schemeClr val="tx2"/>
                 </a:solidFill>
               </a:rPr>
-              <a:t>Team</a:t>
+              <a:t>GROUPED_BY_LABEL</a:t>
             </a:r>
           </a:p>
         </p:txBody>
@@ -22485,7 +22485,7 @@
                   <a:schemeClr val="bg1"/>
                 </a:solidFill>
               </a:rPr>
-              <a:t>PORTFOLIO_PERIOD_MAINT_COMPONENT_ENTANGLEMENT_CHANGE_GROUPED_BY_TEAM</a:t>
+              <a:t>PORTFOLIO_PERIOD_MAINT_COMPONENT_ENTANGLEMENT_CHANGE</a:t>
             </a:r>
           </a:p>
         </p:txBody>
@@ -22904,7 +22904,7 @@
                   <a:schemeClr val="tx2"/>
                 </a:solidFill>
               </a:rPr>
-              <a:t>Team</a:t>
+              <a:t>GROUPED_BY_LABEL</a:t>
             </a:r>
           </a:p>
         </p:txBody>
@@ -23460,7 +23460,7 @@
                   <a:schemeClr val="bg1"/>
                 </a:solidFill>
               </a:rPr>
-              <a:t>PORTFOLIO_PERIOD_ARCH_CODE_BREAKDOWN_GROUPED_BY_TEAM</a:t>
+              <a:t>PORTFOLIO_PERIOD_ARCH_CODE_BREAKDOWN</a:t>
             </a:r>
           </a:p>
         </p:txBody>
@@ -24064,7 +24064,7 @@
                   <a:schemeClr val="tx2"/>
                 </a:solidFill>
               </a:rPr>
-              <a:t>Team</a:t>
+              <a:t>GROUPED_BY_LABEL</a:t>
             </a:r>
           </a:p>
         </p:txBody>
@@ -24416,7 +24416,7 @@
                   <a:schemeClr val="bg1"/>
                 </a:solidFill>
               </a:rPr>
-              <a:t>PORTFOLIO_PERIOD_ARCH_CODE_BREAKDOWN_RATINGS_CHANGE_GROUPED_BY_TEAM</a:t>
+              <a:t>PORTFOLIO_PERIOD_ARCH_CODE_BREAKDOWN_RATINGS_CHANGE</a:t>
             </a:r>
           </a:p>
         </p:txBody>
@@ -24835,7 +24835,7 @@
                   <a:schemeClr val="tx2"/>
                 </a:solidFill>
               </a:rPr>
-              <a:t>Team</a:t>
+              <a:t>GROUPED_BY_LABEL</a:t>
             </a:r>
           </a:p>
         </p:txBody>
@@ -25385,7 +25385,7 @@
                   <a:schemeClr val="bg1"/>
                 </a:solidFill>
               </a:rPr>
-              <a:t>PORTFOLIO_PERIOD_ARCH_COMPONENT_COUPLING_GROUPED_BY_TEAM</a:t>
+              <a:t>PORTFOLIO_PERIOD_ARCH_COMPONENT_COUPLING</a:t>
             </a:r>
           </a:p>
         </p:txBody>
@@ -25989,7 +25989,7 @@
                   <a:schemeClr val="tx2"/>
                 </a:solidFill>
               </a:rPr>
-              <a:t>Team</a:t>
+              <a:t>GROUPED_BY_LABEL</a:t>
             </a:r>
           </a:p>
         </p:txBody>
@@ -26341,7 +26341,7 @@
                   <a:schemeClr val="bg1"/>
                 </a:solidFill>
               </a:rPr>
-              <a:t>PORTFOLIO_PERIOD_ARCH_COMPONENT_COUPLING_RATINGS_CHANGE_GROUPED_BY_TEAM</a:t>
+              <a:t>PORTFOLIO_PERIOD_ARCH_COMPONENT_COUPLING_RATINGS_CHANGE</a:t>
             </a:r>
           </a:p>
         </p:txBody>
@@ -26760,7 +26760,7 @@
                   <a:schemeClr val="tx2"/>
                 </a:solidFill>
               </a:rPr>
-              <a:t>Team</a:t>
+              <a:t>GROUPED_BY_LABEL</a:t>
             </a:r>
           </a:p>
         </p:txBody>
@@ -27048,7 +27048,7 @@
                   <a:schemeClr val="bg1"/>
                 </a:solidFill>
               </a:rPr>
-              <a:t>PORTFOLIO_PERIOD_ARCH_COMPONENT_ADJACENCY_GROUPED_BY_TEAM</a:t>
+              <a:t>PORTFOLIO_PERIOD_ARCH_COMPONENT_ADJACENCY</a:t>
             </a:r>
           </a:p>
         </p:txBody>
@@ -27652,7 +27652,7 @@
                   <a:schemeClr val="tx2"/>
                 </a:solidFill>
               </a:rPr>
-              <a:t>Team</a:t>
+              <a:t>GROUPED_BY_LABEL</a:t>
             </a:r>
           </a:p>
         </p:txBody>
@@ -28004,7 +28004,7 @@
                   <a:schemeClr val="bg1"/>
                 </a:solidFill>
               </a:rPr>
-              <a:t>PORTFOLIO_PERIOD_ARCH_COMPONENT_ADJACENCY_RATINGS_CHANGE_GROUPED_BY_TEAM</a:t>
+              <a:t>PORTFOLIO_PERIOD_ARCH_COMPONENT_ADJACENCY_RATINGS_CHANGE</a:t>
             </a:r>
           </a:p>
         </p:txBody>
@@ -28423,7 +28423,7 @@
                   <a:schemeClr val="tx2"/>
                 </a:solidFill>
               </a:rPr>
-              <a:t>Team</a:t>
+              <a:t>GROUPED_BY_LABEL</a:t>
             </a:r>
           </a:p>
         </p:txBody>
@@ -28711,7 +28711,7 @@
                   <a:schemeClr val="bg1"/>
                 </a:solidFill>
               </a:rPr>
-              <a:t>PORTFOLIO_PERIOD_ARCH_COMPONENT_COHESION_GROUPED_BY_TEAM</a:t>
+              <a:t>PORTFOLIO_PERIOD_ARCH_COMPONENT_COHESION</a:t>
             </a:r>
           </a:p>
         </p:txBody>
@@ -29315,7 +29315,7 @@
                   <a:schemeClr val="tx2"/>
                 </a:solidFill>
               </a:rPr>
-              <a:t>Team</a:t>
+              <a:t>GROUPED_BY_LABEL</a:t>
             </a:r>
           </a:p>
         </p:txBody>
@@ -29667,7 +29667,7 @@
                   <a:schemeClr val="bg1"/>
                 </a:solidFill>
               </a:rPr>
-              <a:t>PORTFOLIO_PERIOD_ARCH_COMPONENT_COHESION_RATINGS_CHANGE_GROUPED_BY_TEAM</a:t>
+              <a:t>PORTFOLIO_PERIOD_ARCH_COMPONENT_COHESION_RATINGS_CHANGE</a:t>
             </a:r>
           </a:p>
         </p:txBody>
@@ -30086,7 +30086,7 @@
                   <a:schemeClr val="tx2"/>
                 </a:solidFill>
               </a:rPr>
-              <a:t>Team</a:t>
+              <a:t>GROUPED_BY_LABEL</a:t>
             </a:r>
           </a:p>
         </p:txBody>
@@ -30400,7 +30400,7 @@
                   <a:schemeClr val="bg1"/>
                 </a:solidFill>
               </a:rPr>
-              <a:t>_GROUPED_BY_TEAM</a:t>
+              <a:t/>
             </a:r>
           </a:p>
         </p:txBody>
@@ -31004,7 +31004,7 @@
                   <a:schemeClr val="tx2"/>
                 </a:solidFill>
               </a:rPr>
-              <a:t>Team</a:t>
+              <a:t>GROUPED_BY_LABEL</a:t>
             </a:r>
           </a:p>
         </p:txBody>
@@ -31391,7 +31391,7 @@
                   <a:schemeClr val="bg1"/>
                 </a:solidFill>
               </a:rPr>
-              <a:t>PORTFOLIO_PERIOD_ARCH_COMMUNICATION_CENTRALIZATION_RATINGS_CHANGE_GROUPED_BY_TEAM</a:t>
+              <a:t>PORTFOLIO_PERIOD_ARCH_COMMUNICATION_CENTRALIZATION_RATINGS_CHANGE</a:t>
             </a:r>
           </a:p>
         </p:txBody>
@@ -31810,7 +31810,7 @@
                   <a:schemeClr val="tx2"/>
                 </a:solidFill>
               </a:rPr>
-              <a:t>Team</a:t>
+              <a:t>GROUPED_BY_LABEL</a:t>
             </a:r>
           </a:p>
         </p:txBody>
@@ -32098,7 +32098,7 @@
                   <a:schemeClr val="bg1"/>
                 </a:solidFill>
               </a:rPr>
-              <a:t>PORTFOLIO_PERIOD_ARCH_DATA_COUPLING_GROUPED_BY_TEAM</a:t>
+              <a:t>PORTFOLIO_PERIOD_ARCH_DATA_COUPLING</a:t>
             </a:r>
           </a:p>
         </p:txBody>
@@ -32702,7 +32702,7 @@
                   <a:schemeClr val="tx2"/>
                 </a:solidFill>
               </a:rPr>
-              <a:t>Team</a:t>
+              <a:t>GROUPED_BY_LABEL</a:t>
             </a:r>
           </a:p>
         </p:txBody>
@@ -33054,7 +33054,7 @@
                   <a:schemeClr val="bg1"/>
                 </a:solidFill>
               </a:rPr>
-              <a:t>PORTFOLIO_PERIOD_ARCH_DATA_COUPLING_RATINGS_CHANGE_GROUPED_BY_TEAM</a:t>
+              <a:t>PORTFOLIO_PERIOD_ARCH_DATA_COUPLING_RATINGS_CHANGE</a:t>
             </a:r>
           </a:p>
         </p:txBody>
@@ -33473,7 +33473,7 @@
                   <a:schemeClr val="tx2"/>
                 </a:solidFill>
               </a:rPr>
-              <a:t>Team</a:t>
+              <a:t>GROUPED_BY_LABEL</a:t>
             </a:r>
           </a:p>
         </p:txBody>
@@ -33680,7 +33680,7 @@
                   <a:schemeClr val="bg1"/>
                 </a:solidFill>
               </a:rPr>
-              <a:t>PORTFOLIO_PERIOD_MAINT_DUPLICATION_GROUPED_BY_TEAM</a:t>
+              <a:t>PORTFOLIO_PERIOD_MAINT_DUPLICATION</a:t>
             </a:r>
           </a:p>
         </p:txBody>
@@ -34284,7 +34284,7 @@
                   <a:schemeClr val="tx2"/>
                 </a:solidFill>
               </a:rPr>
-              <a:t>Team</a:t>
+              <a:t>GROUPED_BY_LABEL</a:t>
             </a:r>
           </a:p>
         </p:txBody>
@@ -34636,7 +34636,7 @@
                   <a:schemeClr val="bg1"/>
                 </a:solidFill>
               </a:rPr>
-              <a:t>PORTFOLIO_PERIOD_ARCH_BOUNDED_EVOLUTION_GROUPED_BY_TEAM</a:t>
+              <a:t>PORTFOLIO_PERIOD_ARCH_BOUNDED_EVOLUTION</a:t>
             </a:r>
           </a:p>
         </p:txBody>
@@ -35240,7 +35240,7 @@
                   <a:schemeClr val="tx2"/>
                 </a:solidFill>
               </a:rPr>
-              <a:t>Team</a:t>
+              <a:t>GROUPED_BY_LABEL</a:t>
             </a:r>
           </a:p>
         </p:txBody>
@@ -35592,7 +35592,7 @@
                   <a:schemeClr val="bg1"/>
                 </a:solidFill>
               </a:rPr>
-              <a:t>PORTFOLIO_PERIOD_ARCH_BOUNDED_EVOLUTION_RATINGS_CHANGE_GROUPED_BY_TEAM</a:t>
+              <a:t>PORTFOLIO_PERIOD_ARCH_BOUNDED_EVOLUTION_RATINGS_CHANGE</a:t>
             </a:r>
           </a:p>
         </p:txBody>
@@ -36011,7 +36011,7 @@
                   <a:schemeClr val="tx2"/>
                 </a:solidFill>
               </a:rPr>
-              <a:t>Team</a:t>
+              <a:t>GROUPED_BY_LABEL</a:t>
             </a:r>
           </a:p>
         </p:txBody>
@@ -36299,7 +36299,7 @@
                   <a:schemeClr val="bg1"/>
                 </a:solidFill>
               </a:rPr>
-              <a:t>PORTFOLIO_PERIOD_ARCH_KNOWLEDGE_AWARENESS_GROUPED_BY_TEAM</a:t>
+              <a:t>PORTFOLIO_PERIOD_ARCH_KNOWLEDGE_AWARENESS</a:t>
             </a:r>
           </a:p>
         </p:txBody>
@@ -36903,7 +36903,7 @@
                   <a:schemeClr val="tx2"/>
                 </a:solidFill>
               </a:rPr>
-              <a:t>Team</a:t>
+              <a:t>GROUPED_BY_LABEL</a:t>
             </a:r>
           </a:p>
         </p:txBody>
@@ -37255,7 +37255,7 @@
                   <a:schemeClr val="bg1"/>
                 </a:solidFill>
               </a:rPr>
-              <a:t>PORTFOLIO_PERIOD_ARCH_KNOWLEDGE_AWARENESS_RATINGS_CHANGE_GROUPED_BY_TEAM</a:t>
+              <a:t>PORTFOLIO_PERIOD_ARCH_KNOWLEDGE_AWARENESS_RATINGS_CHANGE</a:t>
             </a:r>
           </a:p>
         </p:txBody>
@@ -37674,7 +37674,7 @@
                   <a:schemeClr val="tx2"/>
                 </a:solidFill>
               </a:rPr>
-              <a:t>Team</a:t>
+              <a:t>GROUPED_BY_LABEL</a:t>
             </a:r>
           </a:p>
         </p:txBody>
@@ -37962,7 +37962,7 @@
                   <a:schemeClr val="bg1"/>
                 </a:solidFill>
               </a:rPr>
-              <a:t>PORTFOLIO_PERIOD_ARCH_COMPONENT_FRESHNESS_GROUPED_BY_TEAM</a:t>
+              <a:t>PORTFOLIO_PERIOD_ARCH_COMPONENT_FRESHNESS</a:t>
             </a:r>
           </a:p>
         </p:txBody>
@@ -38566,7 +38566,7 @@
                   <a:schemeClr val="tx2"/>
                 </a:solidFill>
               </a:rPr>
-              <a:t>Team</a:t>
+              <a:t>GROUPED_BY_LABEL</a:t>
             </a:r>
           </a:p>
         </p:txBody>
@@ -38918,7 +38918,7 @@
                   <a:schemeClr val="bg1"/>
                 </a:solidFill>
               </a:rPr>
-              <a:t>PORTFOLIO_PERIOD_ARCH_COMPONENT_FRESHNESS_RATINGS_CHANGE_GROUPED_BY_TEAM</a:t>
+              <a:t>PORTFOLIO_PERIOD_ARCH_COMPONENT_FRESHNESS_RATINGS_CHANGE</a:t>
             </a:r>
           </a:p>
         </p:txBody>
@@ -39337,7 +39337,7 @@
                   <a:schemeClr val="tx2"/>
                 </a:solidFill>
               </a:rPr>
-              <a:t>Team</a:t>
+              <a:t>GROUPED_BY_LABEL</a:t>
             </a:r>
           </a:p>
         </p:txBody>
@@ -39625,7 +39625,7 @@
                   <a:schemeClr val="bg1"/>
                 </a:solidFill>
               </a:rPr>
-              <a:t>PORTFOLIO_PERIOD_ARCH_TEAM_STABILITY_GROUPED_BY_TEAM</a:t>
+              <a:t>PORTFOLIO_PERIOD_ARCH_TEAM_STABILITY</a:t>
             </a:r>
           </a:p>
         </p:txBody>
@@ -40229,7 +40229,7 @@
                   <a:schemeClr val="tx2"/>
                 </a:solidFill>
               </a:rPr>
-              <a:t>Team</a:t>
+              <a:t>GROUPED_BY_LABEL</a:t>
             </a:r>
           </a:p>
         </p:txBody>
@@ -40581,7 +40581,7 @@
                   <a:schemeClr val="bg1"/>
                 </a:solidFill>
               </a:rPr>
-              <a:t>PORTFOLIO_PERIOD_ARCH_TEAM_STABILITY_RATINGS_CHANGE_GROUPED_BY_TEAM</a:t>
+              <a:t>PORTFOLIO_PERIOD_ARCH_TEAM_STABILITY_RATINGS_CHANGE</a:t>
             </a:r>
           </a:p>
         </p:txBody>
@@ -41000,7 +41000,7 @@
                   <a:schemeClr val="tx2"/>
                 </a:solidFill>
               </a:rPr>
-              <a:t>Team</a:t>
+              <a:t>GROUPED_BY_LABEL</a:t>
             </a:r>
           </a:p>
         </p:txBody>
@@ -41556,7 +41556,7 @@
                   <a:schemeClr val="bg1"/>
                 </a:solidFill>
               </a:rPr>
-              <a:t>PORTFOLIO_PERIOD_OSH_VULNERABILITY_GROUPED_BY_TEAM</a:t>
+              <a:t>PORTFOLIO_PERIOD_OSH_VULNERABILITY</a:t>
             </a:r>
           </a:p>
         </p:txBody>
@@ -42160,7 +42160,7 @@
                   <a:schemeClr val="tx2"/>
                 </a:solidFill>
               </a:rPr>
-              <a:t>Team</a:t>
+              <a:t>GROUPED_BY_LABEL</a:t>
             </a:r>
           </a:p>
         </p:txBody>
@@ -42512,7 +42512,7 @@
                   <a:schemeClr val="bg1"/>
                 </a:solidFill>
               </a:rPr>
-              <a:t>PORTFOLIO_PERIOD_MAINT_DUPLICATION_CHANGE_GROUPED_BY_TEAM</a:t>
+              <a:t>PORTFOLIO_PERIOD_MAINT_DUPLICATION_CHANGE</a:t>
             </a:r>
           </a:p>
         </p:txBody>
@@ -42931,7 +42931,7 @@
                   <a:schemeClr val="tx2"/>
                 </a:solidFill>
               </a:rPr>
-              <a:t>Team</a:t>
+              <a:t>GROUPED_BY_LABEL</a:t>
             </a:r>
           </a:p>
         </p:txBody>
@@ -43219,7 +43219,7 @@
                   <a:schemeClr val="bg1"/>
                 </a:solidFill>
               </a:rPr>
-              <a:t>PORTFOLIO_PERIOD_OSH_LICENSES_GROUPED_BY_TEAM</a:t>
+              <a:t>PORTFOLIO_PERIOD_OSH_LICENSES</a:t>
             </a:r>
           </a:p>
         </p:txBody>
@@ -43823,7 +43823,7 @@
                   <a:schemeClr val="tx2"/>
                 </a:solidFill>
               </a:rPr>
-              <a:t>Team</a:t>
+              <a:t>GROUPED_BY_LABEL</a:t>
             </a:r>
           </a:p>
         </p:txBody>
@@ -44175,7 +44175,7 @@
                   <a:schemeClr val="bg1"/>
                 </a:solidFill>
               </a:rPr>
-              <a:t>PORTFOLIO_PERIOD_OSH_FRESHNESS_GROUPED_BY_TEAM</a:t>
+              <a:t>PORTFOLIO_PERIOD_OSH_FRESHNESS</a:t>
             </a:r>
           </a:p>
         </p:txBody>
@@ -44779,7 +44779,7 @@
                   <a:schemeClr val="tx2"/>
                 </a:solidFill>
               </a:rPr>
-              <a:t>Team</a:t>
+              <a:t>GROUPED_BY_LABEL</a:t>
             </a:r>
           </a:p>
         </p:txBody>
@@ -45131,7 +45131,7 @@
                   <a:schemeClr val="bg1"/>
                 </a:solidFill>
               </a:rPr>
-              <a:t>PORTFOLIO_PERIOD_OSH_MANAGEMENT_GROUPED_BY_TEAM</a:t>
+              <a:t>PORTFOLIO_PERIOD_OSH_MANAGEMENT</a:t>
             </a:r>
           </a:p>
         </p:txBody>
@@ -45735,7 +45735,7 @@
                   <a:schemeClr val="tx2"/>
                 </a:solidFill>
               </a:rPr>
-              <a:t>Team</a:t>
+              <a:t>GROUPED_BY_LABEL</a:t>
             </a:r>
           </a:p>
         </p:txBody>
@@ -46087,7 +46087,7 @@
                   <a:schemeClr val="bg1"/>
                 </a:solidFill>
               </a:rPr>
-              <a:t>PORTFOLIO_PERIOD_OSH_ACTIVITY_GROUPED_BY_TEAM</a:t>
+              <a:t>PORTFOLIO_PERIOD_OSH_ACTIVITY</a:t>
             </a:r>
           </a:p>
         </p:txBody>
@@ -46133,7 +46133,7 @@
                   <a:schemeClr val="tx2"/>
                 </a:solidFill>
               </a:rPr>
-              <a:t>Team</a:t>
+              <a:t>GROUPED_BY_LABEL</a:t>
             </a:r>
           </a:p>
         </p:txBody>
@@ -47139,7 +47139,7 @@
                   <a:schemeClr val="bg1"/>
                 </a:solidFill>
               </a:rPr>
-              <a:t>PORTFOLIO_PERIOD_MAINT_UNIT_SIZE_GROUPED_BY_TEAM</a:t>
+              <a:t>PORTFOLIO_PERIOD_MAINT_UNIT_SIZE</a:t>
             </a:r>
           </a:p>
         </p:txBody>
@@ -47743,7 +47743,7 @@
                   <a:schemeClr val="tx2"/>
                 </a:solidFill>
               </a:rPr>
-              <a:t>Team</a:t>
+              <a:t>GROUPED_BY_LABEL</a:t>
             </a:r>
           </a:p>
         </p:txBody>
@@ -48095,7 +48095,7 @@
                   <a:schemeClr val="bg1"/>
                 </a:solidFill>
               </a:rPr>
-              <a:t>PORTFOLIO_PERIOD_MAINT_UNIT_SIZE_CHANGE_GROUPED_BY_TEAM</a:t>
+              <a:t>PORTFOLIO_PERIOD_MAINT_UNIT_SIZE_CHANGE</a:t>
             </a:r>
           </a:p>
         </p:txBody>
@@ -48514,7 +48514,7 @@
                   <a:schemeClr val="tx2"/>
                 </a:solidFill>
               </a:rPr>
-              <a:t>Team</a:t>
+              <a:t>GROUPED_BY_LABEL</a:t>
             </a:r>
           </a:p>
         </p:txBody>
@@ -48802,7 +48802,7 @@
                   <a:schemeClr val="bg1"/>
                 </a:solidFill>
               </a:rPr>
-              <a:t>PORTFOLIO_PERIOD_MAINT_UNIT_COMPLEXITY_GROUPED_BY_TEAM</a:t>
+              <a:t>PORTFOLIO_PERIOD_MAINT_UNIT_COMPLEXITY</a:t>
             </a:r>
           </a:p>
         </p:txBody>
@@ -49406,7 +49406,7 @@
                   <a:schemeClr val="tx2"/>
                 </a:solidFill>
               </a:rPr>
-              <a:t>Team</a:t>
+              <a:t>GROUPED_BY_LABEL</a:t>
             </a:r>
           </a:p>
         </p:txBody>
@@ -49758,7 +49758,7 @@
                   <a:schemeClr val="bg1"/>
                 </a:solidFill>
               </a:rPr>
-              <a:t>PORTFOLIO_PERIOD_MAINT_UNIT_COMPLEXITY_CHANGE_GROUPED_BY_TEAM</a:t>
+              <a:t>PORTFOLIO_PERIOD_MAINT_UNIT_COMPLEXITY_CHANGE</a:t>
             </a:r>
           </a:p>
         </p:txBody>
@@ -50177,7 +50177,7 @@
                   <a:schemeClr val="tx2"/>
                 </a:solidFill>
               </a:rPr>
-              <a:t>Team</a:t>
+              <a:t>GROUPED_BY_LABEL</a:t>
             </a:r>
           </a:p>
         </p:txBody>
@@ -50465,7 +50465,7 @@
                   <a:schemeClr val="bg1"/>
                 </a:solidFill>
               </a:rPr>
-              <a:t>PORTFOLIO_PERIOD_MAINT_UNIT_INTERFACING_GROUPED_BY_TEAM</a:t>
+              <a:t>PORTFOLIO_PERIOD_MAINT_UNIT_INTERFACING</a:t>
             </a:r>
           </a:p>
         </p:txBody>
@@ -51069,7 +51069,7 @@
                   <a:schemeClr val="tx2"/>
                 </a:solidFill>
               </a:rPr>
-              <a:t>Team</a:t>
+              <a:t>GROUPED_BY_LABEL</a:t>
             </a:r>
           </a:p>
         </p:txBody>

</xml_diff>